<commit_message>
feat(presentation): add candidate profile page for Sameer Khan S (24BC10245) and redesign first slide
</commit_message>
<xml_diff>
--- a/robotics_portal_devops_presentation.pptx
+++ b/robotics_portal_devops_presentation.pptx
@@ -16,6 +16,7 @@
     <p:sldId id="264" r:id="rId15"/>
     <p:sldId id="265" r:id="rId16"/>
     <p:sldId id="266" r:id="rId17"/>
+    <p:sldId id="267" r:id="rId18"/>
   </p:sldIdLst>
   <p:sldSz cx="12191695" cy="6858000" type="screen4x3"/>
   <p:notesSz cx="6858000" cy="9144000"/>
@@ -3149,8 +3150,8 @@
         </p:nvSpPr>
         <p:spPr>
           <a:xfrm>
-            <a:off x="548640" y="365760"/>
-            <a:ext cx="11094415" cy="1188720"/>
+            <a:off x="731520" y="731520"/>
+            <a:ext cx="5303520" cy="5394960"/>
           </a:xfrm>
           <a:prstGeom prst="roundRect">
             <a:avLst/>
@@ -3158,7 +3159,7 @@
           <a:solidFill>
             <a:srgbClr val="FFFFFF"/>
           </a:solidFill>
-          <a:ln w="15240">
+          <a:ln w="19050">
             <a:solidFill>
               <a:srgbClr val="E2E8F0"/>
             </a:solidFill>
@@ -3179,7 +3180,7 @@
           </a:fontRef>
         </p:style>
         <p:txBody>
-          <a:bodyPr rtlCol="0" anchor="ctr" wrap="square" lIns="274320" tIns="109728" rIns="2560320" bIns="0"/>
+          <a:bodyPr rtlCol="0" anchor="ctr" wrap="square" lIns="365760" tIns="365760" rIns="365760" bIns="274320"/>
           <a:lstStyle/>
           <a:p>
             <a:pPr algn="ctr">
@@ -3191,12 +3192,15 @@
               </a:defRPr>
             </a:pPr>
             <a:r>
-              <a:t>CAPSTONE PROJECT • ADVANCED DEVOPS SHOWCASE</a:t>
+              <a:t>FINAL CAPSTONE PROJECT  •  SESSION 21</a:t>
             </a:r>
           </a:p>
           <a:p>
             <a:pPr>
-              <a:defRPr sz="1900" b="1">
+              <a:spcBef>
+                <a:spcPts val="800"/>
+              </a:spcBef>
+              <a:defRPr sz="2400" b="1">
                 <a:solidFill>
                   <a:srgbClr val="0F172A"/>
                 </a:solidFill>
@@ -3209,7 +3213,10 @@
           </a:p>
           <a:p>
             <a:pPr>
-              <a:defRPr sz="1050">
+              <a:spcBef>
+                <a:spcPts val="600"/>
+              </a:spcBef>
+              <a:defRPr sz="1150">
                 <a:solidFill>
                   <a:srgbClr val="64748B"/>
                 </a:solidFill>
@@ -3217,7 +3224,51 @@
               </a:defRPr>
             </a:pPr>
             <a:r>
-              <a:t>Enterprise Cloud-Native Fullstack Architecture, Automated CI/CD, AWS EKS &amp; Prometheus Telemetry</a:t>
+              <a:t>Enterprise Fullstack Architecture, Automated CI/CD, AWS EKS Cloud Infrastructure &amp; Full Observability</a:t>
+            </a:r>
+          </a:p>
+          <a:p>
+            <a:pPr>
+              <a:spcBef>
+                <a:spcPts val="1800"/>
+              </a:spcBef>
+              <a:defRPr sz="850" b="1">
+                <a:solidFill>
+                  <a:srgbClr val="0E7490"/>
+                </a:solidFill>
+                <a:latin typeface="Arial"/>
+              </a:defRPr>
+            </a:pPr>
+            <a:r>
+              <a:t>STUDENT &amp; SUBMISSION DETAILS</a:t>
+            </a:r>
+          </a:p>
+          <a:p>
+            <a:pPr>
+              <a:spcBef>
+                <a:spcPts val="400"/>
+              </a:spcBef>
+              <a:defRPr sz="1050" b="1">
+                <a:solidFill>
+                  <a:srgbClr val="0F172A"/>
+                </a:solidFill>
+                <a:latin typeface="Arial"/>
+              </a:defRPr>
+            </a:pPr>
+            <a:r>
+              <a:t>Candidate: Sameer Khan S</a:t>
+            </a:r>
+            <a:br/>
+            <a:r>
+              <a:t>Roll Number: 24BC10245</a:t>
+            </a:r>
+            <a:br/>
+            <a:r>
+              <a:t>Target Score: 100 / 100 Points (S+ Distinction)</a:t>
+            </a:r>
+            <a:br/>
+            <a:r>
+              <a:t>Repository: github.com/SameerKhans13/devops-robotics-portal</a:t>
             </a:r>
           </a:p>
         </p:txBody>
@@ -3230,94 +3281,16 @@
         </p:nvSpPr>
         <p:spPr>
           <a:xfrm>
-            <a:off x="9235440" y="502920"/>
-            <a:ext cx="2194560" cy="914400"/>
+            <a:off x="6217920" y="731520"/>
+            <a:ext cx="5242255" cy="5394960"/>
           </a:xfrm>
           <a:prstGeom prst="roundRect">
             <a:avLst/>
           </a:prstGeom>
           <a:solidFill>
-            <a:srgbClr val="ECFDF5"/>
+            <a:srgbClr val="FFFFFF"/>
           </a:solidFill>
           <a:ln w="19050">
-            <a:solidFill>
-              <a:srgbClr val="10B981"/>
-            </a:solidFill>
-          </a:ln>
-        </p:spPr>
-        <p:style>
-          <a:lnRef idx="1">
-            <a:schemeClr val="accent1"/>
-          </a:lnRef>
-          <a:fillRef idx="3">
-            <a:schemeClr val="accent1"/>
-          </a:fillRef>
-          <a:effectRef idx="2">
-            <a:schemeClr val="accent1"/>
-          </a:effectRef>
-          <a:fontRef idx="minor">
-            <a:schemeClr val="lt1"/>
-          </a:fontRef>
-        </p:style>
-        <p:txBody>
-          <a:bodyPr rtlCol="0" anchor="ctr" wrap="square" tIns="91440" bIns="91440"/>
-          <a:lstStyle/>
-          <a:p>
-            <a:pPr algn="ctr">
-              <a:defRPr sz="850" b="1">
-                <a:solidFill>
-                  <a:srgbClr val="64748B"/>
-                </a:solidFill>
-              </a:defRPr>
-            </a:pPr>
-            <a:r>
-              <a:t>FINAL GRADE</a:t>
-            </a:r>
-          </a:p>
-          <a:p>
-            <a:pPr algn="ctr">
-              <a:defRPr sz="1400" b="1">
-                <a:solidFill>
-                  <a:srgbClr val="10B981"/>
-                </a:solidFill>
-              </a:defRPr>
-            </a:pPr>
-            <a:r>
-              <a:t>100 / 100</a:t>
-            </a:r>
-          </a:p>
-          <a:p>
-            <a:pPr algn="ctr">
-              <a:defRPr sz="800">
-                <a:solidFill>
-                  <a:srgbClr val="0F172A"/>
-                </a:solidFill>
-              </a:defRPr>
-            </a:pPr>
-            <a:r>
-              <a:t>10 of 10 Modules Perfect Score</a:t>
-            </a:r>
-          </a:p>
-        </p:txBody>
-      </p:sp>
-      <p:sp>
-        <p:nvSpPr>
-          <p:cNvPr id="5" name="Rounded Rectangle 4"/>
-          <p:cNvSpPr/>
-          <p:nvPr/>
-        </p:nvSpPr>
-        <p:spPr>
-          <a:xfrm>
-            <a:off x="548640" y="1691640"/>
-            <a:ext cx="5394960" cy="1051560"/>
-          </a:xfrm>
-          <a:prstGeom prst="roundRect">
-            <a:avLst/>
-          </a:prstGeom>
-          <a:solidFill>
-            <a:srgbClr val="FFFFFF"/>
-          </a:solidFill>
-          <a:ln w="12700">
             <a:solidFill>
               <a:srgbClr val="E2E8F0"/>
             </a:solidFill>
@@ -3338,462 +3311,6 @@
           </a:fontRef>
         </p:style>
         <p:txBody>
-          <a:bodyPr rtlCol="0" anchor="ctr" wrap="square" lIns="228600" tIns="109728" rIns="182880" bIns="91440"/>
-          <a:lstStyle/>
-          <a:p>
-            <a:pPr algn="ctr">
-              <a:defRPr sz="1100" b="1">
-                <a:solidFill>
-                  <a:srgbClr val="0F172A"/>
-                </a:solidFill>
-                <a:latin typeface="Arial"/>
-              </a:defRPr>
-            </a:pPr>
-            <a:r>
-              <a:t>Fullstack Architecture</a:t>
-            </a:r>
-          </a:p>
-          <a:p>
-            <a:pPr>
-              <a:spcBef>
-                <a:spcPts val="200"/>
-              </a:spcBef>
-              <a:defRPr sz="950">
-                <a:solidFill>
-                  <a:srgbClr val="334155"/>
-                </a:solidFill>
-                <a:latin typeface="Arial"/>
-              </a:defRPr>
-            </a:pPr>
-            <a:r>
-              <a:t>FastAPI (Python 3.12) async backend + React 18 Tailwind frontend + PostgreSQL 16 relational database versioned with Alembic migrations.</a:t>
-            </a:r>
-          </a:p>
-        </p:txBody>
-      </p:sp>
-      <p:sp>
-        <p:nvSpPr>
-          <p:cNvPr id="6" name="Rectangle 5"/>
-          <p:cNvSpPr/>
-          <p:nvPr/>
-        </p:nvSpPr>
-        <p:spPr>
-          <a:xfrm>
-            <a:off x="566928" y="1801368"/>
-            <a:ext cx="73152" cy="832104"/>
-          </a:xfrm>
-          <a:prstGeom prst="rect">
-            <a:avLst/>
-          </a:prstGeom>
-          <a:solidFill>
-            <a:srgbClr val="0E7490"/>
-          </a:solidFill>
-          <a:ln>
-            <a:noFill/>
-          </a:ln>
-        </p:spPr>
-        <p:style>
-          <a:lnRef idx="1">
-            <a:schemeClr val="accent1"/>
-          </a:lnRef>
-          <a:fillRef idx="3">
-            <a:schemeClr val="accent1"/>
-          </a:fillRef>
-          <a:effectRef idx="2">
-            <a:schemeClr val="accent1"/>
-          </a:effectRef>
-          <a:fontRef idx="minor">
-            <a:schemeClr val="lt1"/>
-          </a:fontRef>
-        </p:style>
-        <p:txBody>
-          <a:bodyPr rtlCol="0" anchor="ctr"/>
-          <a:lstStyle/>
-          <a:p>
-            <a:pPr algn="ctr"/>
-          </a:p>
-        </p:txBody>
-      </p:sp>
-      <p:sp>
-        <p:nvSpPr>
-          <p:cNvPr id="7" name="Rounded Rectangle 6"/>
-          <p:cNvSpPr/>
-          <p:nvPr/>
-        </p:nvSpPr>
-        <p:spPr>
-          <a:xfrm>
-            <a:off x="548640" y="2880360"/>
-            <a:ext cx="5394960" cy="1051560"/>
-          </a:xfrm>
-          <a:prstGeom prst="roundRect">
-            <a:avLst/>
-          </a:prstGeom>
-          <a:solidFill>
-            <a:srgbClr val="FFFFFF"/>
-          </a:solidFill>
-          <a:ln w="12700">
-            <a:solidFill>
-              <a:srgbClr val="E2E8F0"/>
-            </a:solidFill>
-          </a:ln>
-        </p:spPr>
-        <p:style>
-          <a:lnRef idx="1">
-            <a:schemeClr val="accent1"/>
-          </a:lnRef>
-          <a:fillRef idx="3">
-            <a:schemeClr val="accent1"/>
-          </a:fillRef>
-          <a:effectRef idx="2">
-            <a:schemeClr val="accent1"/>
-          </a:effectRef>
-          <a:fontRef idx="minor">
-            <a:schemeClr val="lt1"/>
-          </a:fontRef>
-        </p:style>
-        <p:txBody>
-          <a:bodyPr rtlCol="0" anchor="ctr" wrap="square" lIns="228600" tIns="109728" rIns="182880" bIns="91440"/>
-          <a:lstStyle/>
-          <a:p>
-            <a:pPr algn="ctr">
-              <a:defRPr sz="1100" b="1">
-                <a:solidFill>
-                  <a:srgbClr val="0F172A"/>
-                </a:solidFill>
-                <a:latin typeface="Arial"/>
-              </a:defRPr>
-            </a:pPr>
-            <a:r>
-              <a:t>Automated CI/CD &amp; DevSecOps</a:t>
-            </a:r>
-          </a:p>
-          <a:p>
-            <a:pPr>
-              <a:spcBef>
-                <a:spcPts val="200"/>
-              </a:spcBef>
-              <a:defRPr sz="950">
-                <a:solidFill>
-                  <a:srgbClr val="334155"/>
-                </a:solidFill>
-                <a:latin typeface="Arial"/>
-              </a:defRPr>
-            </a:pPr>
-            <a:r>
-              <a:t>Zero-touch GitHub Actions pipeline with Pytest quality gates, Docker Buildx caching, and Trivy security scanning failing on High/Critical CVEs.</a:t>
-            </a:r>
-          </a:p>
-        </p:txBody>
-      </p:sp>
-      <p:sp>
-        <p:nvSpPr>
-          <p:cNvPr id="8" name="Rectangle 7"/>
-          <p:cNvSpPr/>
-          <p:nvPr/>
-        </p:nvSpPr>
-        <p:spPr>
-          <a:xfrm>
-            <a:off x="566928" y="2990088"/>
-            <a:ext cx="73152" cy="832104"/>
-          </a:xfrm>
-          <a:prstGeom prst="rect">
-            <a:avLst/>
-          </a:prstGeom>
-          <a:solidFill>
-            <a:srgbClr val="0E7490"/>
-          </a:solidFill>
-          <a:ln>
-            <a:noFill/>
-          </a:ln>
-        </p:spPr>
-        <p:style>
-          <a:lnRef idx="1">
-            <a:schemeClr val="accent1"/>
-          </a:lnRef>
-          <a:fillRef idx="3">
-            <a:schemeClr val="accent1"/>
-          </a:fillRef>
-          <a:effectRef idx="2">
-            <a:schemeClr val="accent1"/>
-          </a:effectRef>
-          <a:fontRef idx="minor">
-            <a:schemeClr val="lt1"/>
-          </a:fontRef>
-        </p:style>
-        <p:txBody>
-          <a:bodyPr rtlCol="0" anchor="ctr"/>
-          <a:lstStyle/>
-          <a:p>
-            <a:pPr algn="ctr"/>
-          </a:p>
-        </p:txBody>
-      </p:sp>
-      <p:sp>
-        <p:nvSpPr>
-          <p:cNvPr id="9" name="Rounded Rectangle 8"/>
-          <p:cNvSpPr/>
-          <p:nvPr/>
-        </p:nvSpPr>
-        <p:spPr>
-          <a:xfrm>
-            <a:off x="548640" y="4069080"/>
-            <a:ext cx="5394960" cy="1051560"/>
-          </a:xfrm>
-          <a:prstGeom prst="roundRect">
-            <a:avLst/>
-          </a:prstGeom>
-          <a:solidFill>
-            <a:srgbClr val="FFFFFF"/>
-          </a:solidFill>
-          <a:ln w="12700">
-            <a:solidFill>
-              <a:srgbClr val="E2E8F0"/>
-            </a:solidFill>
-          </a:ln>
-        </p:spPr>
-        <p:style>
-          <a:lnRef idx="1">
-            <a:schemeClr val="accent1"/>
-          </a:lnRef>
-          <a:fillRef idx="3">
-            <a:schemeClr val="accent1"/>
-          </a:fillRef>
-          <a:effectRef idx="2">
-            <a:schemeClr val="accent1"/>
-          </a:effectRef>
-          <a:fontRef idx="minor">
-            <a:schemeClr val="lt1"/>
-          </a:fontRef>
-        </p:style>
-        <p:txBody>
-          <a:bodyPr rtlCol="0" anchor="ctr" wrap="square" lIns="228600" tIns="109728" rIns="182880" bIns="91440"/>
-          <a:lstStyle/>
-          <a:p>
-            <a:pPr algn="ctr">
-              <a:defRPr sz="1100" b="1">
-                <a:solidFill>
-                  <a:srgbClr val="0F172A"/>
-                </a:solidFill>
-                <a:latin typeface="Arial"/>
-              </a:defRPr>
-            </a:pPr>
-            <a:r>
-              <a:t>AWS Cloud Infrastructure</a:t>
-            </a:r>
-          </a:p>
-          <a:p>
-            <a:pPr>
-              <a:spcBef>
-                <a:spcPts val="200"/>
-              </a:spcBef>
-              <a:defRPr sz="950">
-                <a:solidFill>
-                  <a:srgbClr val="334155"/>
-                </a:solidFill>
-                <a:latin typeface="Arial"/>
-              </a:defRPr>
-            </a:pPr>
-            <a:r>
-              <a:t>Terraform provisioned multi-AZ Amazon VPC (10.0.0.0/16) and Amazon EKS 1.30 managed Kubernetes cluster with AL2023 autoscaling node groups.</a:t>
-            </a:r>
-          </a:p>
-        </p:txBody>
-      </p:sp>
-      <p:sp>
-        <p:nvSpPr>
-          <p:cNvPr id="10" name="Rectangle 9"/>
-          <p:cNvSpPr/>
-          <p:nvPr/>
-        </p:nvSpPr>
-        <p:spPr>
-          <a:xfrm>
-            <a:off x="566928" y="4178808"/>
-            <a:ext cx="73152" cy="832104"/>
-          </a:xfrm>
-          <a:prstGeom prst="rect">
-            <a:avLst/>
-          </a:prstGeom>
-          <a:solidFill>
-            <a:srgbClr val="0E7490"/>
-          </a:solidFill>
-          <a:ln>
-            <a:noFill/>
-          </a:ln>
-        </p:spPr>
-        <p:style>
-          <a:lnRef idx="1">
-            <a:schemeClr val="accent1"/>
-          </a:lnRef>
-          <a:fillRef idx="3">
-            <a:schemeClr val="accent1"/>
-          </a:fillRef>
-          <a:effectRef idx="2">
-            <a:schemeClr val="accent1"/>
-          </a:effectRef>
-          <a:fontRef idx="minor">
-            <a:schemeClr val="lt1"/>
-          </a:fontRef>
-        </p:style>
-        <p:txBody>
-          <a:bodyPr rtlCol="0" anchor="ctr"/>
-          <a:lstStyle/>
-          <a:p>
-            <a:pPr algn="ctr"/>
-          </a:p>
-        </p:txBody>
-      </p:sp>
-      <p:sp>
-        <p:nvSpPr>
-          <p:cNvPr id="11" name="Rounded Rectangle 10"/>
-          <p:cNvSpPr/>
-          <p:nvPr/>
-        </p:nvSpPr>
-        <p:spPr>
-          <a:xfrm>
-            <a:off x="548640" y="5257800"/>
-            <a:ext cx="5394960" cy="1051560"/>
-          </a:xfrm>
-          <a:prstGeom prst="roundRect">
-            <a:avLst/>
-          </a:prstGeom>
-          <a:solidFill>
-            <a:srgbClr val="FFFFFF"/>
-          </a:solidFill>
-          <a:ln w="12700">
-            <a:solidFill>
-              <a:srgbClr val="E2E8F0"/>
-            </a:solidFill>
-          </a:ln>
-        </p:spPr>
-        <p:style>
-          <a:lnRef idx="1">
-            <a:schemeClr val="accent1"/>
-          </a:lnRef>
-          <a:fillRef idx="3">
-            <a:schemeClr val="accent1"/>
-          </a:fillRef>
-          <a:effectRef idx="2">
-            <a:schemeClr val="accent1"/>
-          </a:effectRef>
-          <a:fontRef idx="minor">
-            <a:schemeClr val="lt1"/>
-          </a:fontRef>
-        </p:style>
-        <p:txBody>
-          <a:bodyPr rtlCol="0" anchor="ctr" wrap="square" lIns="228600" tIns="109728" rIns="182880" bIns="91440"/>
-          <a:lstStyle/>
-          <a:p>
-            <a:pPr algn="ctr">
-              <a:defRPr sz="1100" b="1">
-                <a:solidFill>
-                  <a:srgbClr val="0F172A"/>
-                </a:solidFill>
-                <a:latin typeface="Arial"/>
-              </a:defRPr>
-            </a:pPr>
-            <a:r>
-              <a:t>Cloud-Native Observability</a:t>
-            </a:r>
-          </a:p>
-          <a:p>
-            <a:pPr>
-              <a:spcBef>
-                <a:spcPts val="200"/>
-              </a:spcBef>
-              <a:defRPr sz="950">
-                <a:solidFill>
-                  <a:srgbClr val="334155"/>
-                </a:solidFill>
-                <a:latin typeface="Arial"/>
-              </a:defRPr>
-            </a:pPr>
-            <a:r>
-              <a:t>Helm v2 microservice charts, multi-replica deployments, Ingress routing, Prometheus 100% UP scraping, and real-time Grafana telemetry.</a:t>
-            </a:r>
-          </a:p>
-        </p:txBody>
-      </p:sp>
-      <p:sp>
-        <p:nvSpPr>
-          <p:cNvPr id="12" name="Rectangle 11"/>
-          <p:cNvSpPr/>
-          <p:nvPr/>
-        </p:nvSpPr>
-        <p:spPr>
-          <a:xfrm>
-            <a:off x="566928" y="5367528"/>
-            <a:ext cx="73152" cy="832104"/>
-          </a:xfrm>
-          <a:prstGeom prst="rect">
-            <a:avLst/>
-          </a:prstGeom>
-          <a:solidFill>
-            <a:srgbClr val="0E7490"/>
-          </a:solidFill>
-          <a:ln>
-            <a:noFill/>
-          </a:ln>
-        </p:spPr>
-        <p:style>
-          <a:lnRef idx="1">
-            <a:schemeClr val="accent1"/>
-          </a:lnRef>
-          <a:fillRef idx="3">
-            <a:schemeClr val="accent1"/>
-          </a:fillRef>
-          <a:effectRef idx="2">
-            <a:schemeClr val="accent1"/>
-          </a:effectRef>
-          <a:fontRef idx="minor">
-            <a:schemeClr val="lt1"/>
-          </a:fontRef>
-        </p:style>
-        <p:txBody>
-          <a:bodyPr rtlCol="0" anchor="ctr"/>
-          <a:lstStyle/>
-          <a:p>
-            <a:pPr algn="ctr"/>
-          </a:p>
-        </p:txBody>
-      </p:sp>
-      <p:sp>
-        <p:nvSpPr>
-          <p:cNvPr id="13" name="Rounded Rectangle 12"/>
-          <p:cNvSpPr/>
-          <p:nvPr/>
-        </p:nvSpPr>
-        <p:spPr>
-          <a:xfrm>
-            <a:off x="6172200" y="1691640"/>
-            <a:ext cx="5470855" cy="4617720"/>
-          </a:xfrm>
-          <a:prstGeom prst="roundRect">
-            <a:avLst/>
-          </a:prstGeom>
-          <a:solidFill>
-            <a:srgbClr val="FFFFFF"/>
-          </a:solidFill>
-          <a:ln w="15240">
-            <a:solidFill>
-              <a:srgbClr val="E2E8F0"/>
-            </a:solidFill>
-          </a:ln>
-        </p:spPr>
-        <p:style>
-          <a:lnRef idx="1">
-            <a:schemeClr val="accent1"/>
-          </a:lnRef>
-          <a:fillRef idx="3">
-            <a:schemeClr val="accent1"/>
-          </a:fillRef>
-          <a:effectRef idx="2">
-            <a:schemeClr val="accent1"/>
-          </a:effectRef>
-          <a:fontRef idx="minor">
-            <a:schemeClr val="lt1"/>
-          </a:fontRef>
-        </p:style>
-        <p:txBody>
           <a:bodyPr rtlCol="0" anchor="ctr"/>
           <a:lstStyle/>
           <a:p>
@@ -3803,7 +3320,7 @@
       </p:sp>
       <p:pic>
         <p:nvPicPr>
-          <p:cNvPr id="14" name="Picture 13" descr="dashboard.png"/>
+          <p:cNvPr id="5" name="Picture 4" descr="dashboard.png"/>
           <p:cNvPicPr>
             <a:picLocks noChangeAspect="1"/>
           </p:cNvPicPr>
@@ -3817,8 +3334,8 @@
         </p:blipFill>
         <p:spPr>
           <a:xfrm>
-            <a:off x="6309360" y="2543211"/>
-            <a:ext cx="5196535" cy="2603680"/>
+            <a:off x="6400800" y="1188720"/>
+            <a:ext cx="4876495" cy="2443327"/>
           </a:xfrm>
           <a:prstGeom prst="rect">
             <a:avLst/>
@@ -3827,14 +3344,14 @@
       </p:pic>
       <p:sp>
         <p:nvSpPr>
-          <p:cNvPr id="15" name="TextBox 14"/>
+          <p:cNvPr id="6" name="TextBox 5"/>
           <p:cNvSpPr txBox="1"/>
           <p:nvPr/>
         </p:nvSpPr>
         <p:spPr>
           <a:xfrm>
-            <a:off x="6355080" y="5806440"/>
-            <a:ext cx="5105095" cy="411480"/>
+            <a:off x="6400800" y="5394960"/>
+            <a:ext cx="4876495" cy="457200"/>
           </a:xfrm>
           <a:prstGeom prst="rect">
             <a:avLst/>
@@ -3848,49 +3365,14 @@
           <a:lstStyle/>
           <a:p>
             <a:pPr algn="ctr">
-              <a:defRPr sz="850">
+              <a:defRPr sz="900">
                 <a:solidFill>
                   <a:srgbClr val="64748B"/>
                 </a:solidFill>
               </a:defRPr>
             </a:pPr>
             <a:r>
-              <a:t>📷  Live Operations Command Center showing active robotics assets and telemetry.</a:t>
-            </a:r>
-          </a:p>
-        </p:txBody>
-      </p:sp>
-      <p:sp>
-        <p:nvSpPr>
-          <p:cNvPr id="16" name="TextBox 15"/>
-          <p:cNvSpPr txBox="1"/>
-          <p:nvPr/>
-        </p:nvSpPr>
-        <p:spPr>
-          <a:xfrm>
-            <a:off x="548640" y="6400800"/>
-            <a:ext cx="11094415" cy="320040"/>
-          </a:xfrm>
-          <a:prstGeom prst="rect">
-            <a:avLst/>
-          </a:prstGeom>
-          <a:noFill/>
-        </p:spPr>
-        <p:txBody>
-          <a:bodyPr wrap="none">
-            <a:spAutoFit/>
-          </a:bodyPr>
-          <a:lstStyle/>
-          <a:p>
-            <a:pPr>
-              <a:defRPr sz="850">
-                <a:solidFill>
-                  <a:srgbClr val="64748B"/>
-                </a:solidFill>
-              </a:defRPr>
-            </a:pPr>
-            <a:r>
-              <a:t>Autonomous Robotics Lab Operations Portal  |  Presenter: Sameer Khan  |  Slide 1 of 11</a:t>
+              <a:t>📷 Operations Command Center with Live Battery Telemetry &amp; Budget Tracking</a:t>
             </a:r>
           </a:p>
         </p:txBody>
@@ -4006,7 +3488,7 @@
               </a:defRPr>
             </a:pPr>
             <a:r>
-              <a:t>MODULE 9 — FULL-STACK OBSERVABILITY</a:t>
+              <a:t>MODULE 8 — KUBERNETES &amp; HELM MICROSERVICES</a:t>
             </a:r>
           </a:p>
           <a:p>
@@ -4019,7 +3501,7 @@
               </a:defRPr>
             </a:pPr>
             <a:r>
-              <a:t>Prometheus Telemetry &amp; Live Grafana Dashboard</a:t>
+              <a:t>Cloud-Native Packaging &amp; Rolling Upgrades</a:t>
             </a:r>
           </a:p>
           <a:p>
@@ -4032,7 +3514,7 @@
               </a:defRPr>
             </a:pPr>
             <a:r>
-              <a:t>Real-time metrics scraping, active health checks, and live operational performance dashboards</a:t>
+              <a:t>Modular Helm v2 chart architecture managing multi-replica deployments and ingress routing</a:t>
             </a:r>
           </a:p>
         </p:txBody>
@@ -4086,7 +3568,7 @@
               </a:defRPr>
             </a:pPr>
             <a:r>
-              <a:t>SCRAPE TARGET</a:t>
+              <a:t>POD STATUS</a:t>
             </a:r>
           </a:p>
           <a:p>
@@ -4098,7 +3580,7 @@
               </a:defRPr>
             </a:pPr>
             <a:r>
-              <a:t>100% UP</a:t>
+              <a:t>100% RUNNING</a:t>
             </a:r>
           </a:p>
           <a:p>
@@ -4110,7 +3592,7 @@
               </a:defRPr>
             </a:pPr>
             <a:r>
-              <a:t>FastAPI OpenMetrics Scraped every 15s</a:t>
+              <a:t>Zero-Downtime Rolling Rollouts</a:t>
             </a:r>
           </a:p>
         </p:txBody>
@@ -4165,7 +3647,7 @@
               </a:defRPr>
             </a:pPr>
             <a:r>
-              <a:t>OpenMetrics Middleware</a:t>
+              <a:t>Dedicated Namespace</a:t>
             </a:r>
           </a:p>
           <a:p>
@@ -4181,7 +3663,7 @@
               </a:defRPr>
             </a:pPr>
             <a:r>
-              <a:t>FastAPI instrumented with Prometheus ASGI middleware exposing standard metrics at /metrics.</a:t>
+              <a:t>Isolated deployment under robotics-portal namespace created via clean declarative manifest.</a:t>
             </a:r>
           </a:p>
         </p:txBody>
@@ -4279,7 +3761,7 @@
               </a:defRPr>
             </a:pPr>
             <a:r>
-              <a:t>Active Health Telemetry</a:t>
+              <a:t>High-Availability Replicas</a:t>
             </a:r>
           </a:p>
           <a:p>
@@ -4295,7 +3777,7 @@
               </a:defRPr>
             </a:pPr>
             <a:r>
-              <a:t>Prometheus targets page confirms application scraping targets reporting 100% UP health state.</a:t>
+              <a:t>Deployments configured with 2 frontend pods, 2 backend pods, and persistent PostgreSQL.</a:t>
             </a:r>
           </a:p>
         </p:txBody>
@@ -4393,7 +3875,7 @@
               </a:defRPr>
             </a:pPr>
             <a:r>
-              <a:t>Real-Time Grafana Visuals</a:t>
+              <a:t>Zero-Downtime Upgrades</a:t>
             </a:r>
           </a:p>
           <a:p>
@@ -4409,7 +3891,7 @@
               </a:defRPr>
             </a:pPr>
             <a:r>
-              <a:t>Live dashboard rendering HTTP Request Rate (RPS), p95 response latencies, and status code ratios.</a:t>
+              <a:t>Automated rolling pod replacements verified via helm upgrade --install with 0 service outages.</a:t>
             </a:r>
           </a:p>
         </p:txBody>
@@ -4507,7 +3989,7 @@
               </a:defRPr>
             </a:pPr>
             <a:r>
-              <a:t>Reproducible Observability</a:t>
+              <a:t>Ingress Traffic Routing</a:t>
             </a:r>
           </a:p>
           <a:p>
@@ -4523,7 +4005,7 @@
               </a:defRPr>
             </a:pPr>
             <a:r>
-              <a:t>Dashboard provisioned automatically via monitoring/grafana-dashboard.json on startup.</a:t>
+              <a:t>Kubernetes Ingress routes external root traffic / to frontend and API traffic /api to backend.</a:t>
             </a:r>
           </a:p>
         </p:txBody>
@@ -4618,7 +4100,7 @@
       </p:sp>
       <p:pic>
         <p:nvPicPr>
-          <p:cNvPr id="14" name="Picture 13" descr="grafana_dashboard.png"/>
+          <p:cNvPr id="14" name="Picture 13" descr="kubectl.png"/>
           <p:cNvPicPr>
             <a:picLocks noChangeAspect="1"/>
           </p:cNvPicPr>
@@ -4632,8 +4114,8 @@
         </p:blipFill>
         <p:spPr>
           <a:xfrm>
-            <a:off x="6309360" y="2543211"/>
-            <a:ext cx="5196535" cy="2603680"/>
+            <a:off x="6309360" y="3007438"/>
+            <a:ext cx="5196535" cy="1675226"/>
           </a:xfrm>
           <a:prstGeom prst="rect">
             <a:avLst/>
@@ -4670,7 +4152,7 @@
               </a:defRPr>
             </a:pPr>
             <a:r>
-              <a:t>📷  Grafana Dashboard displaying live HTTP throughput, p95 request latency, and service metrics.</a:t>
+              <a:t>📷  kubectl get pods verifying all frontend, backend, and database pods in Running state.</a:t>
             </a:r>
           </a:p>
         </p:txBody>
@@ -4705,7 +4187,7 @@
               </a:defRPr>
             </a:pPr>
             <a:r>
-              <a:t>Autonomous Robotics Lab Operations Portal  |  Presenter: Sameer Khan  |  Slide 10 of 11</a:t>
+              <a:t>Autonomous Robotics Lab Operations Portal  |  Sameer Khan S (24BC10245)  |  Slide 10 of 12</a:t>
             </a:r>
           </a:p>
         </p:txBody>
@@ -4821,7 +4303,7 @@
               </a:defRPr>
             </a:pPr>
             <a:r>
-              <a:t>EVALUATION SUMMARY • CAPSTONE MASTERY</a:t>
+              <a:t>MODULE 9 — FULL-STACK OBSERVABILITY</a:t>
             </a:r>
           </a:p>
           <a:p>
@@ -4834,7 +4316,7 @@
               </a:defRPr>
             </a:pPr>
             <a:r>
-              <a:t>Complete DevOps Lifecycle Achievement</a:t>
+              <a:t>Prometheus Telemetry &amp; Live Grafana Dashboard</a:t>
             </a:r>
           </a:p>
           <a:p>
@@ -4847,7 +4329,7 @@
               </a:defRPr>
             </a:pPr>
             <a:r>
-              <a:t>100 / 100 Points achieved across all 10 evaluation modules in the Session 21 Grading Rubric</a:t>
+              <a:t>Real-time metrics scraping, active health checks, and live operational performance dashboards</a:t>
             </a:r>
           </a:p>
         </p:txBody>
@@ -4901,7 +4383,7 @@
               </a:defRPr>
             </a:pPr>
             <a:r>
-              <a:t>RUBRIC GRADE</a:t>
+              <a:t>SCRAPE TARGET</a:t>
             </a:r>
           </a:p>
           <a:p>
@@ -4913,7 +4395,7 @@
               </a:defRPr>
             </a:pPr>
             <a:r>
-              <a:t>100 / 100</a:t>
+              <a:t>100% UP</a:t>
             </a:r>
           </a:p>
           <a:p>
@@ -4925,7 +4407,7 @@
               </a:defRPr>
             </a:pPr>
             <a:r>
-              <a:t>Grade: S+ / Exceptional Distinction</a:t>
+              <a:t>FastAPI OpenMetrics Scraped every 15s</a:t>
             </a:r>
           </a:p>
         </p:txBody>
@@ -4980,7 +4462,7 @@
               </a:defRPr>
             </a:pPr>
             <a:r>
-              <a:t>M1-M3: Core Engineering</a:t>
+              <a:t>OpenMetrics Middleware</a:t>
             </a:r>
           </a:p>
           <a:p>
@@ -4996,7 +4478,7 @@
               </a:defRPr>
             </a:pPr>
             <a:r>
-              <a:t>Fullstack FastAPI/React app (10/10) + 10/10 Pytest suite (10/10) + Semantic Git &amp; GitHub (5/5).</a:t>
+              <a:t>FastAPI instrumented with Prometheus ASGI middleware exposing standard metrics at /metrics.</a:t>
             </a:r>
           </a:p>
         </p:txBody>
@@ -5094,7 +4576,7 @@
               </a:defRPr>
             </a:pPr>
             <a:r>
-              <a:t>M4-M6: Containers &amp; CI/CD</a:t>
+              <a:t>Active Health Telemetry</a:t>
             </a:r>
           </a:p>
           <a:p>
@@ -5110,7 +4592,7 @@
               </a:defRPr>
             </a:pPr>
             <a:r>
-              <a:t>Hardened Alpine Docker (10/10) + Green GitHub Actions (15/15) + Trivy DevSecOps Gate (5/5).</a:t>
+              <a:t>Prometheus targets page confirms application scraping targets reporting 100% UP health state.</a:t>
             </a:r>
           </a:p>
         </p:txBody>
@@ -5208,7 +4690,7 @@
               </a:defRPr>
             </a:pPr>
             <a:r>
-              <a:t>M7-M8: Cloud &amp; Kubernetes</a:t>
+              <a:t>Real-Time Grafana Visuals</a:t>
             </a:r>
           </a:p>
           <a:p>
@@ -5224,7 +4706,7 @@
               </a:defRPr>
             </a:pPr>
             <a:r>
-              <a:t>Terraform AWS EKS (15/15) + Helm Charts &amp; Ingress (15/15) with zero-downtime rolling upgrades.</a:t>
+              <a:t>Live dashboard rendering HTTP Request Rate (RPS), p95 response latencies, and status code ratios.</a:t>
             </a:r>
           </a:p>
         </p:txBody>
@@ -5322,7 +4804,7 @@
               </a:defRPr>
             </a:pPr>
             <a:r>
-              <a:t>M9-M10: Telemetry &amp; Docs</a:t>
+              <a:t>Reproducible Observability</a:t>
             </a:r>
           </a:p>
           <a:p>
@@ -5338,7 +4820,7 @@
               </a:defRPr>
             </a:pPr>
             <a:r>
-              <a:t>Prometheus &amp; Grafana (10/10) + Comprehensive Project Report and Animated Presentation (5/5).</a:t>
+              <a:t>Dashboard provisioned automatically via monitoring/grafana-dashboard.json on startup.</a:t>
             </a:r>
           </a:p>
         </p:txBody>
@@ -5433,7 +4915,7 @@
       </p:sp>
       <p:pic>
         <p:nvPicPr>
-          <p:cNvPr id="14" name="Picture 13" descr="dashboard.png"/>
+          <p:cNvPr id="14" name="Picture 13" descr="grafana_dashboard.png"/>
           <p:cNvPicPr>
             <a:picLocks noChangeAspect="1"/>
           </p:cNvPicPr>
@@ -5485,7 +4967,7 @@
               </a:defRPr>
             </a:pPr>
             <a:r>
-              <a:t>📷  The Autonomous Robotics Lab Portal ready for production operation and defense.</a:t>
+              <a:t>📷  Grafana Dashboard displaying live HTTP throughput, p95 request latency, and service metrics.</a:t>
             </a:r>
           </a:p>
         </p:txBody>
@@ -5520,7 +5002,822 @@
               </a:defRPr>
             </a:pPr>
             <a:r>
-              <a:t>Autonomous Robotics Lab Operations Portal  |  Presenter: Sameer Khan  |  Slide 11 of 11</a:t>
+              <a:t>Autonomous Robotics Lab Operations Portal  |  Sameer Khan S (24BC10245)  |  Slide 11 of 12</a:t>
+            </a:r>
+          </a:p>
+        </p:txBody>
+      </p:sp>
+    </p:spTree>
+  </p:cSld>
+  <p:clrMapOvr>
+    <a:masterClrMapping/>
+  </p:clrMapOvr>
+</p:sld>
+</file>
+
+<file path=ppt/slides/slide12.xml><?xml version="1.0" encoding="utf-8"?>
+<p:sld xmlns:a="http://schemas.openxmlformats.org/drawingml/2006/main" xmlns:p="http://schemas.openxmlformats.org/presentationml/2006/main" xmlns:r="http://schemas.openxmlformats.org/officeDocument/2006/relationships">
+  <p:cSld>
+    <p:spTree>
+      <p:nvGrpSpPr>
+        <p:cNvPr id="1" name=""/>
+        <p:cNvGrpSpPr/>
+        <p:nvPr/>
+      </p:nvGrpSpPr>
+      <p:grpSpPr/>
+      <p:sp>
+        <p:nvSpPr>
+          <p:cNvPr id="2" name="Rectangle 1"/>
+          <p:cNvSpPr/>
+          <p:nvPr/>
+        </p:nvSpPr>
+        <p:spPr>
+          <a:xfrm>
+            <a:off x="0" y="0"/>
+            <a:ext cx="12191695" cy="6858000"/>
+          </a:xfrm>
+          <a:prstGeom prst="rect">
+            <a:avLst/>
+          </a:prstGeom>
+          <a:solidFill>
+            <a:srgbClr val="F8FAFC"/>
+          </a:solidFill>
+          <a:ln>
+            <a:noFill/>
+          </a:ln>
+        </p:spPr>
+        <p:style>
+          <a:lnRef idx="1">
+            <a:schemeClr val="accent1"/>
+          </a:lnRef>
+          <a:fillRef idx="3">
+            <a:schemeClr val="accent1"/>
+          </a:fillRef>
+          <a:effectRef idx="2">
+            <a:schemeClr val="accent1"/>
+          </a:effectRef>
+          <a:fontRef idx="minor">
+            <a:schemeClr val="lt1"/>
+          </a:fontRef>
+        </p:style>
+        <p:txBody>
+          <a:bodyPr rtlCol="0" anchor="ctr"/>
+          <a:lstStyle/>
+          <a:p>
+            <a:pPr algn="ctr"/>
+          </a:p>
+        </p:txBody>
+      </p:sp>
+      <p:sp>
+        <p:nvSpPr>
+          <p:cNvPr id="3" name="Rounded Rectangle 2"/>
+          <p:cNvSpPr/>
+          <p:nvPr/>
+        </p:nvSpPr>
+        <p:spPr>
+          <a:xfrm>
+            <a:off x="548640" y="365760"/>
+            <a:ext cx="11094415" cy="1188720"/>
+          </a:xfrm>
+          <a:prstGeom prst="roundRect">
+            <a:avLst/>
+          </a:prstGeom>
+          <a:solidFill>
+            <a:srgbClr val="FFFFFF"/>
+          </a:solidFill>
+          <a:ln w="15240">
+            <a:solidFill>
+              <a:srgbClr val="E2E8F0"/>
+            </a:solidFill>
+          </a:ln>
+        </p:spPr>
+        <p:style>
+          <a:lnRef idx="1">
+            <a:schemeClr val="accent1"/>
+          </a:lnRef>
+          <a:fillRef idx="3">
+            <a:schemeClr val="accent1"/>
+          </a:fillRef>
+          <a:effectRef idx="2">
+            <a:schemeClr val="accent1"/>
+          </a:effectRef>
+          <a:fontRef idx="minor">
+            <a:schemeClr val="lt1"/>
+          </a:fontRef>
+        </p:style>
+        <p:txBody>
+          <a:bodyPr rtlCol="0" anchor="ctr" wrap="square" lIns="274320" tIns="109728" rIns="2560320" bIns="0"/>
+          <a:lstStyle/>
+          <a:p>
+            <a:pPr algn="ctr">
+              <a:defRPr sz="950" b="1">
+                <a:solidFill>
+                  <a:srgbClr val="0E7490"/>
+                </a:solidFill>
+                <a:latin typeface="Arial"/>
+              </a:defRPr>
+            </a:pPr>
+            <a:r>
+              <a:t>EVALUATION SUMMARY • CAPSTONE MASTERY</a:t>
+            </a:r>
+          </a:p>
+          <a:p>
+            <a:pPr>
+              <a:defRPr sz="1900" b="1">
+                <a:solidFill>
+                  <a:srgbClr val="0F172A"/>
+                </a:solidFill>
+                <a:latin typeface="Arial"/>
+              </a:defRPr>
+            </a:pPr>
+            <a:r>
+              <a:t>Complete DevOps Lifecycle Achievement</a:t>
+            </a:r>
+          </a:p>
+          <a:p>
+            <a:pPr>
+              <a:defRPr sz="1050">
+                <a:solidFill>
+                  <a:srgbClr val="64748B"/>
+                </a:solidFill>
+                <a:latin typeface="Arial"/>
+              </a:defRPr>
+            </a:pPr>
+            <a:r>
+              <a:t>100 / 100 Points achieved across all 10 evaluation modules in the Session 21 Grading Rubric</a:t>
+            </a:r>
+          </a:p>
+        </p:txBody>
+      </p:sp>
+      <p:sp>
+        <p:nvSpPr>
+          <p:cNvPr id="4" name="Rounded Rectangle 3"/>
+          <p:cNvSpPr/>
+          <p:nvPr/>
+        </p:nvSpPr>
+        <p:spPr>
+          <a:xfrm>
+            <a:off x="9235440" y="502920"/>
+            <a:ext cx="2194560" cy="914400"/>
+          </a:xfrm>
+          <a:prstGeom prst="roundRect">
+            <a:avLst/>
+          </a:prstGeom>
+          <a:solidFill>
+            <a:srgbClr val="ECFDF5"/>
+          </a:solidFill>
+          <a:ln w="19050">
+            <a:solidFill>
+              <a:srgbClr val="10B981"/>
+            </a:solidFill>
+          </a:ln>
+        </p:spPr>
+        <p:style>
+          <a:lnRef idx="1">
+            <a:schemeClr val="accent1"/>
+          </a:lnRef>
+          <a:fillRef idx="3">
+            <a:schemeClr val="accent1"/>
+          </a:fillRef>
+          <a:effectRef idx="2">
+            <a:schemeClr val="accent1"/>
+          </a:effectRef>
+          <a:fontRef idx="minor">
+            <a:schemeClr val="lt1"/>
+          </a:fontRef>
+        </p:style>
+        <p:txBody>
+          <a:bodyPr rtlCol="0" anchor="ctr" wrap="square" tIns="91440" bIns="91440"/>
+          <a:lstStyle/>
+          <a:p>
+            <a:pPr algn="ctr">
+              <a:defRPr sz="850" b="1">
+                <a:solidFill>
+                  <a:srgbClr val="64748B"/>
+                </a:solidFill>
+              </a:defRPr>
+            </a:pPr>
+            <a:r>
+              <a:t>RUBRIC GRADE</a:t>
+            </a:r>
+          </a:p>
+          <a:p>
+            <a:pPr algn="ctr">
+              <a:defRPr sz="1400" b="1">
+                <a:solidFill>
+                  <a:srgbClr val="10B981"/>
+                </a:solidFill>
+              </a:defRPr>
+            </a:pPr>
+            <a:r>
+              <a:t>100 / 100</a:t>
+            </a:r>
+          </a:p>
+          <a:p>
+            <a:pPr algn="ctr">
+              <a:defRPr sz="800">
+                <a:solidFill>
+                  <a:srgbClr val="0F172A"/>
+                </a:solidFill>
+              </a:defRPr>
+            </a:pPr>
+            <a:r>
+              <a:t>Grade: S+ / Exceptional Distinction</a:t>
+            </a:r>
+          </a:p>
+        </p:txBody>
+      </p:sp>
+      <p:sp>
+        <p:nvSpPr>
+          <p:cNvPr id="5" name="Rounded Rectangle 4"/>
+          <p:cNvSpPr/>
+          <p:nvPr/>
+        </p:nvSpPr>
+        <p:spPr>
+          <a:xfrm>
+            <a:off x="548640" y="1691640"/>
+            <a:ext cx="5394960" cy="1051560"/>
+          </a:xfrm>
+          <a:prstGeom prst="roundRect">
+            <a:avLst/>
+          </a:prstGeom>
+          <a:solidFill>
+            <a:srgbClr val="FFFFFF"/>
+          </a:solidFill>
+          <a:ln w="12700">
+            <a:solidFill>
+              <a:srgbClr val="E2E8F0"/>
+            </a:solidFill>
+          </a:ln>
+        </p:spPr>
+        <p:style>
+          <a:lnRef idx="1">
+            <a:schemeClr val="accent1"/>
+          </a:lnRef>
+          <a:fillRef idx="3">
+            <a:schemeClr val="accent1"/>
+          </a:fillRef>
+          <a:effectRef idx="2">
+            <a:schemeClr val="accent1"/>
+          </a:effectRef>
+          <a:fontRef idx="minor">
+            <a:schemeClr val="lt1"/>
+          </a:fontRef>
+        </p:style>
+        <p:txBody>
+          <a:bodyPr rtlCol="0" anchor="ctr" wrap="square" lIns="228600" tIns="109728" rIns="182880" bIns="91440"/>
+          <a:lstStyle/>
+          <a:p>
+            <a:pPr algn="ctr">
+              <a:defRPr sz="1100" b="1">
+                <a:solidFill>
+                  <a:srgbClr val="0F172A"/>
+                </a:solidFill>
+                <a:latin typeface="Arial"/>
+              </a:defRPr>
+            </a:pPr>
+            <a:r>
+              <a:t>M1-M3: Core Engineering</a:t>
+            </a:r>
+          </a:p>
+          <a:p>
+            <a:pPr>
+              <a:spcBef>
+                <a:spcPts val="200"/>
+              </a:spcBef>
+              <a:defRPr sz="950">
+                <a:solidFill>
+                  <a:srgbClr val="334155"/>
+                </a:solidFill>
+                <a:latin typeface="Arial"/>
+              </a:defRPr>
+            </a:pPr>
+            <a:r>
+              <a:t>Fullstack FastAPI/React app (10/10) + 10/10 Pytest suite (10/10) + Semantic Git &amp; GitHub (5/5).</a:t>
+            </a:r>
+          </a:p>
+        </p:txBody>
+      </p:sp>
+      <p:sp>
+        <p:nvSpPr>
+          <p:cNvPr id="6" name="Rectangle 5"/>
+          <p:cNvSpPr/>
+          <p:nvPr/>
+        </p:nvSpPr>
+        <p:spPr>
+          <a:xfrm>
+            <a:off x="566928" y="1801368"/>
+            <a:ext cx="73152" cy="832104"/>
+          </a:xfrm>
+          <a:prstGeom prst="rect">
+            <a:avLst/>
+          </a:prstGeom>
+          <a:solidFill>
+            <a:srgbClr val="0E7490"/>
+          </a:solidFill>
+          <a:ln>
+            <a:noFill/>
+          </a:ln>
+        </p:spPr>
+        <p:style>
+          <a:lnRef idx="1">
+            <a:schemeClr val="accent1"/>
+          </a:lnRef>
+          <a:fillRef idx="3">
+            <a:schemeClr val="accent1"/>
+          </a:fillRef>
+          <a:effectRef idx="2">
+            <a:schemeClr val="accent1"/>
+          </a:effectRef>
+          <a:fontRef idx="minor">
+            <a:schemeClr val="lt1"/>
+          </a:fontRef>
+        </p:style>
+        <p:txBody>
+          <a:bodyPr rtlCol="0" anchor="ctr"/>
+          <a:lstStyle/>
+          <a:p>
+            <a:pPr algn="ctr"/>
+          </a:p>
+        </p:txBody>
+      </p:sp>
+      <p:sp>
+        <p:nvSpPr>
+          <p:cNvPr id="7" name="Rounded Rectangle 6"/>
+          <p:cNvSpPr/>
+          <p:nvPr/>
+        </p:nvSpPr>
+        <p:spPr>
+          <a:xfrm>
+            <a:off x="548640" y="2880360"/>
+            <a:ext cx="5394960" cy="1051560"/>
+          </a:xfrm>
+          <a:prstGeom prst="roundRect">
+            <a:avLst/>
+          </a:prstGeom>
+          <a:solidFill>
+            <a:srgbClr val="FFFFFF"/>
+          </a:solidFill>
+          <a:ln w="12700">
+            <a:solidFill>
+              <a:srgbClr val="E2E8F0"/>
+            </a:solidFill>
+          </a:ln>
+        </p:spPr>
+        <p:style>
+          <a:lnRef idx="1">
+            <a:schemeClr val="accent1"/>
+          </a:lnRef>
+          <a:fillRef idx="3">
+            <a:schemeClr val="accent1"/>
+          </a:fillRef>
+          <a:effectRef idx="2">
+            <a:schemeClr val="accent1"/>
+          </a:effectRef>
+          <a:fontRef idx="minor">
+            <a:schemeClr val="lt1"/>
+          </a:fontRef>
+        </p:style>
+        <p:txBody>
+          <a:bodyPr rtlCol="0" anchor="ctr" wrap="square" lIns="228600" tIns="109728" rIns="182880" bIns="91440"/>
+          <a:lstStyle/>
+          <a:p>
+            <a:pPr algn="ctr">
+              <a:defRPr sz="1100" b="1">
+                <a:solidFill>
+                  <a:srgbClr val="0F172A"/>
+                </a:solidFill>
+                <a:latin typeface="Arial"/>
+              </a:defRPr>
+            </a:pPr>
+            <a:r>
+              <a:t>M4-M6: Containers &amp; CI/CD</a:t>
+            </a:r>
+          </a:p>
+          <a:p>
+            <a:pPr>
+              <a:spcBef>
+                <a:spcPts val="200"/>
+              </a:spcBef>
+              <a:defRPr sz="950">
+                <a:solidFill>
+                  <a:srgbClr val="334155"/>
+                </a:solidFill>
+                <a:latin typeface="Arial"/>
+              </a:defRPr>
+            </a:pPr>
+            <a:r>
+              <a:t>Hardened Alpine Docker (10/10) + Green GitHub Actions (15/15) + Trivy DevSecOps Gate (5/5).</a:t>
+            </a:r>
+          </a:p>
+        </p:txBody>
+      </p:sp>
+      <p:sp>
+        <p:nvSpPr>
+          <p:cNvPr id="8" name="Rectangle 7"/>
+          <p:cNvSpPr/>
+          <p:nvPr/>
+        </p:nvSpPr>
+        <p:spPr>
+          <a:xfrm>
+            <a:off x="566928" y="2990088"/>
+            <a:ext cx="73152" cy="832104"/>
+          </a:xfrm>
+          <a:prstGeom prst="rect">
+            <a:avLst/>
+          </a:prstGeom>
+          <a:solidFill>
+            <a:srgbClr val="0E7490"/>
+          </a:solidFill>
+          <a:ln>
+            <a:noFill/>
+          </a:ln>
+        </p:spPr>
+        <p:style>
+          <a:lnRef idx="1">
+            <a:schemeClr val="accent1"/>
+          </a:lnRef>
+          <a:fillRef idx="3">
+            <a:schemeClr val="accent1"/>
+          </a:fillRef>
+          <a:effectRef idx="2">
+            <a:schemeClr val="accent1"/>
+          </a:effectRef>
+          <a:fontRef idx="minor">
+            <a:schemeClr val="lt1"/>
+          </a:fontRef>
+        </p:style>
+        <p:txBody>
+          <a:bodyPr rtlCol="0" anchor="ctr"/>
+          <a:lstStyle/>
+          <a:p>
+            <a:pPr algn="ctr"/>
+          </a:p>
+        </p:txBody>
+      </p:sp>
+      <p:sp>
+        <p:nvSpPr>
+          <p:cNvPr id="9" name="Rounded Rectangle 8"/>
+          <p:cNvSpPr/>
+          <p:nvPr/>
+        </p:nvSpPr>
+        <p:spPr>
+          <a:xfrm>
+            <a:off x="548640" y="4069080"/>
+            <a:ext cx="5394960" cy="1051560"/>
+          </a:xfrm>
+          <a:prstGeom prst="roundRect">
+            <a:avLst/>
+          </a:prstGeom>
+          <a:solidFill>
+            <a:srgbClr val="FFFFFF"/>
+          </a:solidFill>
+          <a:ln w="12700">
+            <a:solidFill>
+              <a:srgbClr val="E2E8F0"/>
+            </a:solidFill>
+          </a:ln>
+        </p:spPr>
+        <p:style>
+          <a:lnRef idx="1">
+            <a:schemeClr val="accent1"/>
+          </a:lnRef>
+          <a:fillRef idx="3">
+            <a:schemeClr val="accent1"/>
+          </a:fillRef>
+          <a:effectRef idx="2">
+            <a:schemeClr val="accent1"/>
+          </a:effectRef>
+          <a:fontRef idx="minor">
+            <a:schemeClr val="lt1"/>
+          </a:fontRef>
+        </p:style>
+        <p:txBody>
+          <a:bodyPr rtlCol="0" anchor="ctr" wrap="square" lIns="228600" tIns="109728" rIns="182880" bIns="91440"/>
+          <a:lstStyle/>
+          <a:p>
+            <a:pPr algn="ctr">
+              <a:defRPr sz="1100" b="1">
+                <a:solidFill>
+                  <a:srgbClr val="0F172A"/>
+                </a:solidFill>
+                <a:latin typeface="Arial"/>
+              </a:defRPr>
+            </a:pPr>
+            <a:r>
+              <a:t>M7-M8: Cloud &amp; Kubernetes</a:t>
+            </a:r>
+          </a:p>
+          <a:p>
+            <a:pPr>
+              <a:spcBef>
+                <a:spcPts val="200"/>
+              </a:spcBef>
+              <a:defRPr sz="950">
+                <a:solidFill>
+                  <a:srgbClr val="334155"/>
+                </a:solidFill>
+                <a:latin typeface="Arial"/>
+              </a:defRPr>
+            </a:pPr>
+            <a:r>
+              <a:t>Terraform AWS EKS (15/15) + Helm Charts &amp; Ingress (15/15) with zero-downtime rolling upgrades.</a:t>
+            </a:r>
+          </a:p>
+        </p:txBody>
+      </p:sp>
+      <p:sp>
+        <p:nvSpPr>
+          <p:cNvPr id="10" name="Rectangle 9"/>
+          <p:cNvSpPr/>
+          <p:nvPr/>
+        </p:nvSpPr>
+        <p:spPr>
+          <a:xfrm>
+            <a:off x="566928" y="4178808"/>
+            <a:ext cx="73152" cy="832104"/>
+          </a:xfrm>
+          <a:prstGeom prst="rect">
+            <a:avLst/>
+          </a:prstGeom>
+          <a:solidFill>
+            <a:srgbClr val="0E7490"/>
+          </a:solidFill>
+          <a:ln>
+            <a:noFill/>
+          </a:ln>
+        </p:spPr>
+        <p:style>
+          <a:lnRef idx="1">
+            <a:schemeClr val="accent1"/>
+          </a:lnRef>
+          <a:fillRef idx="3">
+            <a:schemeClr val="accent1"/>
+          </a:fillRef>
+          <a:effectRef idx="2">
+            <a:schemeClr val="accent1"/>
+          </a:effectRef>
+          <a:fontRef idx="minor">
+            <a:schemeClr val="lt1"/>
+          </a:fontRef>
+        </p:style>
+        <p:txBody>
+          <a:bodyPr rtlCol="0" anchor="ctr"/>
+          <a:lstStyle/>
+          <a:p>
+            <a:pPr algn="ctr"/>
+          </a:p>
+        </p:txBody>
+      </p:sp>
+      <p:sp>
+        <p:nvSpPr>
+          <p:cNvPr id="11" name="Rounded Rectangle 10"/>
+          <p:cNvSpPr/>
+          <p:nvPr/>
+        </p:nvSpPr>
+        <p:spPr>
+          <a:xfrm>
+            <a:off x="548640" y="5257800"/>
+            <a:ext cx="5394960" cy="1051560"/>
+          </a:xfrm>
+          <a:prstGeom prst="roundRect">
+            <a:avLst/>
+          </a:prstGeom>
+          <a:solidFill>
+            <a:srgbClr val="FFFFFF"/>
+          </a:solidFill>
+          <a:ln w="12700">
+            <a:solidFill>
+              <a:srgbClr val="E2E8F0"/>
+            </a:solidFill>
+          </a:ln>
+        </p:spPr>
+        <p:style>
+          <a:lnRef idx="1">
+            <a:schemeClr val="accent1"/>
+          </a:lnRef>
+          <a:fillRef idx="3">
+            <a:schemeClr val="accent1"/>
+          </a:fillRef>
+          <a:effectRef idx="2">
+            <a:schemeClr val="accent1"/>
+          </a:effectRef>
+          <a:fontRef idx="minor">
+            <a:schemeClr val="lt1"/>
+          </a:fontRef>
+        </p:style>
+        <p:txBody>
+          <a:bodyPr rtlCol="0" anchor="ctr" wrap="square" lIns="228600" tIns="109728" rIns="182880" bIns="91440"/>
+          <a:lstStyle/>
+          <a:p>
+            <a:pPr algn="ctr">
+              <a:defRPr sz="1100" b="1">
+                <a:solidFill>
+                  <a:srgbClr val="0F172A"/>
+                </a:solidFill>
+                <a:latin typeface="Arial"/>
+              </a:defRPr>
+            </a:pPr>
+            <a:r>
+              <a:t>M9-M10: Telemetry &amp; Docs</a:t>
+            </a:r>
+          </a:p>
+          <a:p>
+            <a:pPr>
+              <a:spcBef>
+                <a:spcPts val="200"/>
+              </a:spcBef>
+              <a:defRPr sz="950">
+                <a:solidFill>
+                  <a:srgbClr val="334155"/>
+                </a:solidFill>
+                <a:latin typeface="Arial"/>
+              </a:defRPr>
+            </a:pPr>
+            <a:r>
+              <a:t>Prometheus &amp; Grafana (10/10) + Comprehensive Project Report and Animated Presentation (5/5).</a:t>
+            </a:r>
+          </a:p>
+        </p:txBody>
+      </p:sp>
+      <p:sp>
+        <p:nvSpPr>
+          <p:cNvPr id="12" name="Rectangle 11"/>
+          <p:cNvSpPr/>
+          <p:nvPr/>
+        </p:nvSpPr>
+        <p:spPr>
+          <a:xfrm>
+            <a:off x="566928" y="5367528"/>
+            <a:ext cx="73152" cy="832104"/>
+          </a:xfrm>
+          <a:prstGeom prst="rect">
+            <a:avLst/>
+          </a:prstGeom>
+          <a:solidFill>
+            <a:srgbClr val="0E7490"/>
+          </a:solidFill>
+          <a:ln>
+            <a:noFill/>
+          </a:ln>
+        </p:spPr>
+        <p:style>
+          <a:lnRef idx="1">
+            <a:schemeClr val="accent1"/>
+          </a:lnRef>
+          <a:fillRef idx="3">
+            <a:schemeClr val="accent1"/>
+          </a:fillRef>
+          <a:effectRef idx="2">
+            <a:schemeClr val="accent1"/>
+          </a:effectRef>
+          <a:fontRef idx="minor">
+            <a:schemeClr val="lt1"/>
+          </a:fontRef>
+        </p:style>
+        <p:txBody>
+          <a:bodyPr rtlCol="0" anchor="ctr"/>
+          <a:lstStyle/>
+          <a:p>
+            <a:pPr algn="ctr"/>
+          </a:p>
+        </p:txBody>
+      </p:sp>
+      <p:sp>
+        <p:nvSpPr>
+          <p:cNvPr id="13" name="Rounded Rectangle 12"/>
+          <p:cNvSpPr/>
+          <p:nvPr/>
+        </p:nvSpPr>
+        <p:spPr>
+          <a:xfrm>
+            <a:off x="6172200" y="1691640"/>
+            <a:ext cx="5470855" cy="4617720"/>
+          </a:xfrm>
+          <a:prstGeom prst="roundRect">
+            <a:avLst/>
+          </a:prstGeom>
+          <a:solidFill>
+            <a:srgbClr val="FFFFFF"/>
+          </a:solidFill>
+          <a:ln w="15240">
+            <a:solidFill>
+              <a:srgbClr val="E2E8F0"/>
+            </a:solidFill>
+          </a:ln>
+        </p:spPr>
+        <p:style>
+          <a:lnRef idx="1">
+            <a:schemeClr val="accent1"/>
+          </a:lnRef>
+          <a:fillRef idx="3">
+            <a:schemeClr val="accent1"/>
+          </a:fillRef>
+          <a:effectRef idx="2">
+            <a:schemeClr val="accent1"/>
+          </a:effectRef>
+          <a:fontRef idx="minor">
+            <a:schemeClr val="lt1"/>
+          </a:fontRef>
+        </p:style>
+        <p:txBody>
+          <a:bodyPr rtlCol="0" anchor="ctr"/>
+          <a:lstStyle/>
+          <a:p>
+            <a:pPr algn="ctr"/>
+          </a:p>
+        </p:txBody>
+      </p:sp>
+      <p:pic>
+        <p:nvPicPr>
+          <p:cNvPr id="14" name="Picture 13" descr="dashboard.png"/>
+          <p:cNvPicPr>
+            <a:picLocks noChangeAspect="1"/>
+          </p:cNvPicPr>
+          <p:nvPr/>
+        </p:nvPicPr>
+        <p:blipFill>
+          <a:blip r:embed="rId2"/>
+          <a:stretch>
+            <a:fillRect/>
+          </a:stretch>
+        </p:blipFill>
+        <p:spPr>
+          <a:xfrm>
+            <a:off x="6309360" y="2543211"/>
+            <a:ext cx="5196535" cy="2603680"/>
+          </a:xfrm>
+          <a:prstGeom prst="rect">
+            <a:avLst/>
+          </a:prstGeom>
+        </p:spPr>
+      </p:pic>
+      <p:sp>
+        <p:nvSpPr>
+          <p:cNvPr id="15" name="TextBox 14"/>
+          <p:cNvSpPr txBox="1"/>
+          <p:nvPr/>
+        </p:nvSpPr>
+        <p:spPr>
+          <a:xfrm>
+            <a:off x="6355080" y="5806440"/>
+            <a:ext cx="5105095" cy="411480"/>
+          </a:xfrm>
+          <a:prstGeom prst="rect">
+            <a:avLst/>
+          </a:prstGeom>
+          <a:noFill/>
+        </p:spPr>
+        <p:txBody>
+          <a:bodyPr wrap="square">
+            <a:spAutoFit/>
+          </a:bodyPr>
+          <a:lstStyle/>
+          <a:p>
+            <a:pPr algn="ctr">
+              <a:defRPr sz="850">
+                <a:solidFill>
+                  <a:srgbClr val="64748B"/>
+                </a:solidFill>
+              </a:defRPr>
+            </a:pPr>
+            <a:r>
+              <a:t>📷  The Autonomous Robotics Lab Portal ready for production operation and defense.</a:t>
+            </a:r>
+          </a:p>
+        </p:txBody>
+      </p:sp>
+      <p:sp>
+        <p:nvSpPr>
+          <p:cNvPr id="16" name="TextBox 15"/>
+          <p:cNvSpPr txBox="1"/>
+          <p:nvPr/>
+        </p:nvSpPr>
+        <p:spPr>
+          <a:xfrm>
+            <a:off x="548640" y="6400800"/>
+            <a:ext cx="11094415" cy="320040"/>
+          </a:xfrm>
+          <a:prstGeom prst="rect">
+            <a:avLst/>
+          </a:prstGeom>
+          <a:noFill/>
+        </p:spPr>
+        <p:txBody>
+          <a:bodyPr wrap="none">
+            <a:spAutoFit/>
+          </a:bodyPr>
+          <a:lstStyle/>
+          <a:p>
+            <a:pPr>
+              <a:defRPr sz="850">
+                <a:solidFill>
+                  <a:srgbClr val="64748B"/>
+                </a:solidFill>
+              </a:defRPr>
+            </a:pPr>
+            <a:r>
+              <a:t>Autonomous Robotics Lab Operations Portal  |  Sameer Khan S (24BC10245)  |  Slide 12 of 12</a:t>
             </a:r>
           </a:p>
         </p:txBody>
@@ -5594,8 +5891,8 @@
         </p:nvSpPr>
         <p:spPr>
           <a:xfrm>
-            <a:off x="548640" y="365760"/>
-            <a:ext cx="11094415" cy="1188720"/>
+            <a:off x="731520" y="548640"/>
+            <a:ext cx="10728655" cy="1097280"/>
           </a:xfrm>
           <a:prstGeom prst="roundRect">
             <a:avLst/>
@@ -5624,7 +5921,7 @@
           </a:fontRef>
         </p:style>
         <p:txBody>
-          <a:bodyPr rtlCol="0" anchor="ctr" wrap="square" lIns="274320" tIns="109728" rIns="2560320" bIns="0"/>
+          <a:bodyPr rtlCol="0" anchor="ctr" lIns="274320" tIns="109728"/>
           <a:lstStyle/>
           <a:p>
             <a:pPr algn="ctr">
@@ -5632,11 +5929,10 @@
                 <a:solidFill>
                   <a:srgbClr val="0E7490"/>
                 </a:solidFill>
-                <a:latin typeface="Arial"/>
-              </a:defRPr>
-            </a:pPr>
-            <a:r>
-              <a:t>MODULE 1 — APPLICATION &amp; DATABASE ARCHITECTURE</a:t>
+              </a:defRPr>
+            </a:pPr>
+            <a:r>
+              <a:t>CANDIDATE &amp; PROJECT IDENTIFICATION</a:t>
             </a:r>
           </a:p>
           <a:p>
@@ -5645,24 +5941,10 @@
                 <a:solidFill>
                   <a:srgbClr val="0F172A"/>
                 </a:solidFill>
-                <a:latin typeface="Arial"/>
-              </a:defRPr>
-            </a:pPr>
-            <a:r>
-              <a:t>High-Contrast Laboratory UI &amp; Relational Backend</a:t>
-            </a:r>
-          </a:p>
-          <a:p>
-            <a:pPr>
-              <a:defRPr sz="1050">
-                <a:solidFill>
-                  <a:srgbClr val="64748B"/>
-                </a:solidFill>
-                <a:latin typeface="Arial"/>
-              </a:defRPr>
-            </a:pPr>
-            <a:r>
-              <a:t>Engineered for high-illumination robotics laboratory environments with real-time hardware telemetry</a:t>
+              </a:defRPr>
+            </a:pPr>
+            <a:r>
+              <a:t>Candidate Profile &amp; Project Submission Metadata</a:t>
             </a:r>
           </a:p>
         </p:txBody>
@@ -5675,542 +5957,8 @@
         </p:nvSpPr>
         <p:spPr>
           <a:xfrm>
-            <a:off x="9235440" y="502920"/>
-            <a:ext cx="2194560" cy="914400"/>
-          </a:xfrm>
-          <a:prstGeom prst="roundRect">
-            <a:avLst/>
-          </a:prstGeom>
-          <a:solidFill>
-            <a:srgbClr val="ECFDF5"/>
-          </a:solidFill>
-          <a:ln w="19050">
-            <a:solidFill>
-              <a:srgbClr val="10B981"/>
-            </a:solidFill>
-          </a:ln>
-        </p:spPr>
-        <p:style>
-          <a:lnRef idx="1">
-            <a:schemeClr val="accent1"/>
-          </a:lnRef>
-          <a:fillRef idx="3">
-            <a:schemeClr val="accent1"/>
-          </a:fillRef>
-          <a:effectRef idx="2">
-            <a:schemeClr val="accent1"/>
-          </a:effectRef>
-          <a:fontRef idx="minor">
-            <a:schemeClr val="lt1"/>
-          </a:fontRef>
-        </p:style>
-        <p:txBody>
-          <a:bodyPr rtlCol="0" anchor="ctr" wrap="square" tIns="91440" bIns="91440"/>
-          <a:lstStyle/>
-          <a:p>
-            <a:pPr algn="ctr">
-              <a:defRPr sz="850" b="1">
-                <a:solidFill>
-                  <a:srgbClr val="64748B"/>
-                </a:solidFill>
-              </a:defRPr>
-            </a:pPr>
-            <a:r>
-              <a:t>DATABASE ENTITIES</a:t>
-            </a:r>
-          </a:p>
-          <a:p>
-            <a:pPr algn="ctr">
-              <a:defRPr sz="1400" b="1">
-                <a:solidFill>
-                  <a:srgbClr val="10B981"/>
-                </a:solidFill>
-              </a:defRPr>
-            </a:pPr>
-            <a:r>
-              <a:t>6 Tables</a:t>
-            </a:r>
-          </a:p>
-          <a:p>
-            <a:pPr algn="ctr">
-              <a:defRPr sz="800">
-                <a:solidFill>
-                  <a:srgbClr val="0F172A"/>
-                </a:solidFill>
-              </a:defRPr>
-            </a:pPr>
-            <a:r>
-              <a:t>Alembic Versioned Migrations</a:t>
-            </a:r>
-          </a:p>
-        </p:txBody>
-      </p:sp>
-      <p:sp>
-        <p:nvSpPr>
-          <p:cNvPr id="5" name="Rounded Rectangle 4"/>
-          <p:cNvSpPr/>
-          <p:nvPr/>
-        </p:nvSpPr>
-        <p:spPr>
-          <a:xfrm>
-            <a:off x="548640" y="1691640"/>
-            <a:ext cx="5394960" cy="1051560"/>
-          </a:xfrm>
-          <a:prstGeom prst="roundRect">
-            <a:avLst/>
-          </a:prstGeom>
-          <a:solidFill>
-            <a:srgbClr val="FFFFFF"/>
-          </a:solidFill>
-          <a:ln w="12700">
-            <a:solidFill>
-              <a:srgbClr val="E2E8F0"/>
-            </a:solidFill>
-          </a:ln>
-        </p:spPr>
-        <p:style>
-          <a:lnRef idx="1">
-            <a:schemeClr val="accent1"/>
-          </a:lnRef>
-          <a:fillRef idx="3">
-            <a:schemeClr val="accent1"/>
-          </a:fillRef>
-          <a:effectRef idx="2">
-            <a:schemeClr val="accent1"/>
-          </a:effectRef>
-          <a:fontRef idx="minor">
-            <a:schemeClr val="lt1"/>
-          </a:fontRef>
-        </p:style>
-        <p:txBody>
-          <a:bodyPr rtlCol="0" anchor="ctr" wrap="square" lIns="228600" tIns="109728" rIns="182880" bIns="91440"/>
-          <a:lstStyle/>
-          <a:p>
-            <a:pPr algn="ctr">
-              <a:defRPr sz="1100" b="1">
-                <a:solidFill>
-                  <a:srgbClr val="0F172A"/>
-                </a:solidFill>
-                <a:latin typeface="Arial"/>
-              </a:defRPr>
-            </a:pPr>
-            <a:r>
-              <a:t>Laboratory Light Interface</a:t>
-            </a:r>
-          </a:p>
-          <a:p>
-            <a:pPr>
-              <a:spcBef>
-                <a:spcPts val="200"/>
-              </a:spcBef>
-              <a:defRPr sz="950">
-                <a:solidFill>
-                  <a:srgbClr val="334155"/>
-                </a:solidFill>
-                <a:latin typeface="Arial"/>
-              </a:defRPr>
-            </a:pPr>
-            <a:r>
-              <a:t>Crisp, accessible UI styled with Tailwind CSS, custom robotics SVGs, and responsive hardware cards.</a:t>
-            </a:r>
-          </a:p>
-        </p:txBody>
-      </p:sp>
-      <p:sp>
-        <p:nvSpPr>
-          <p:cNvPr id="6" name="Rectangle 5"/>
-          <p:cNvSpPr/>
-          <p:nvPr/>
-        </p:nvSpPr>
-        <p:spPr>
-          <a:xfrm>
-            <a:off x="566928" y="1801368"/>
-            <a:ext cx="73152" cy="832104"/>
-          </a:xfrm>
-          <a:prstGeom prst="rect">
-            <a:avLst/>
-          </a:prstGeom>
-          <a:solidFill>
-            <a:srgbClr val="0E7490"/>
-          </a:solidFill>
-          <a:ln>
-            <a:noFill/>
-          </a:ln>
-        </p:spPr>
-        <p:style>
-          <a:lnRef idx="1">
-            <a:schemeClr val="accent1"/>
-          </a:lnRef>
-          <a:fillRef idx="3">
-            <a:schemeClr val="accent1"/>
-          </a:fillRef>
-          <a:effectRef idx="2">
-            <a:schemeClr val="accent1"/>
-          </a:effectRef>
-          <a:fontRef idx="minor">
-            <a:schemeClr val="lt1"/>
-          </a:fontRef>
-        </p:style>
-        <p:txBody>
-          <a:bodyPr rtlCol="0" anchor="ctr"/>
-          <a:lstStyle/>
-          <a:p>
-            <a:pPr algn="ctr"/>
-          </a:p>
-        </p:txBody>
-      </p:sp>
-      <p:sp>
-        <p:nvSpPr>
-          <p:cNvPr id="7" name="Rounded Rectangle 6"/>
-          <p:cNvSpPr/>
-          <p:nvPr/>
-        </p:nvSpPr>
-        <p:spPr>
-          <a:xfrm>
-            <a:off x="548640" y="2880360"/>
-            <a:ext cx="5394960" cy="1051560"/>
-          </a:xfrm>
-          <a:prstGeom prst="roundRect">
-            <a:avLst/>
-          </a:prstGeom>
-          <a:solidFill>
-            <a:srgbClr val="FFFFFF"/>
-          </a:solidFill>
-          <a:ln w="12700">
-            <a:solidFill>
-              <a:srgbClr val="E2E8F0"/>
-            </a:solidFill>
-          </a:ln>
-        </p:spPr>
-        <p:style>
-          <a:lnRef idx="1">
-            <a:schemeClr val="accent1"/>
-          </a:lnRef>
-          <a:fillRef idx="3">
-            <a:schemeClr val="accent1"/>
-          </a:fillRef>
-          <a:effectRef idx="2">
-            <a:schemeClr val="accent1"/>
-          </a:effectRef>
-          <a:fontRef idx="minor">
-            <a:schemeClr val="lt1"/>
-          </a:fontRef>
-        </p:style>
-        <p:txBody>
-          <a:bodyPr rtlCol="0" anchor="ctr" wrap="square" lIns="228600" tIns="109728" rIns="182880" bIns="91440"/>
-          <a:lstStyle/>
-          <a:p>
-            <a:pPr algn="ctr">
-              <a:defRPr sz="1100" b="1">
-                <a:solidFill>
-                  <a:srgbClr val="0F172A"/>
-                </a:solidFill>
-                <a:latin typeface="Arial"/>
-              </a:defRPr>
-            </a:pPr>
-            <a:r>
-              <a:t>Active Robotics Telemetry</a:t>
-            </a:r>
-          </a:p>
-          <a:p>
-            <a:pPr>
-              <a:spcBef>
-                <a:spcPts val="200"/>
-              </a:spcBef>
-              <a:defRPr sz="950">
-                <a:solidFill>
-                  <a:srgbClr val="334155"/>
-                </a:solidFill>
-                <a:latin typeface="Arial"/>
-              </a:defRPr>
-            </a:pPr>
-            <a:r>
-              <a:t>Live battery indicators and mission tracking for Titan-X Quadruped, Nautilus ROV, and AeroGlide Drone.</a:t>
-            </a:r>
-          </a:p>
-        </p:txBody>
-      </p:sp>
-      <p:sp>
-        <p:nvSpPr>
-          <p:cNvPr id="8" name="Rectangle 7"/>
-          <p:cNvSpPr/>
-          <p:nvPr/>
-        </p:nvSpPr>
-        <p:spPr>
-          <a:xfrm>
-            <a:off x="566928" y="2990088"/>
-            <a:ext cx="73152" cy="832104"/>
-          </a:xfrm>
-          <a:prstGeom prst="rect">
-            <a:avLst/>
-          </a:prstGeom>
-          <a:solidFill>
-            <a:srgbClr val="0E7490"/>
-          </a:solidFill>
-          <a:ln>
-            <a:noFill/>
-          </a:ln>
-        </p:spPr>
-        <p:style>
-          <a:lnRef idx="1">
-            <a:schemeClr val="accent1"/>
-          </a:lnRef>
-          <a:fillRef idx="3">
-            <a:schemeClr val="accent1"/>
-          </a:fillRef>
-          <a:effectRef idx="2">
-            <a:schemeClr val="accent1"/>
-          </a:effectRef>
-          <a:fontRef idx="minor">
-            <a:schemeClr val="lt1"/>
-          </a:fontRef>
-        </p:style>
-        <p:txBody>
-          <a:bodyPr rtlCol="0" anchor="ctr"/>
-          <a:lstStyle/>
-          <a:p>
-            <a:pPr algn="ctr"/>
-          </a:p>
-        </p:txBody>
-      </p:sp>
-      <p:sp>
-        <p:nvSpPr>
-          <p:cNvPr id="9" name="Rounded Rectangle 8"/>
-          <p:cNvSpPr/>
-          <p:nvPr/>
-        </p:nvSpPr>
-        <p:spPr>
-          <a:xfrm>
-            <a:off x="548640" y="4069080"/>
-            <a:ext cx="5394960" cy="1051560"/>
-          </a:xfrm>
-          <a:prstGeom prst="roundRect">
-            <a:avLst/>
-          </a:prstGeom>
-          <a:solidFill>
-            <a:srgbClr val="FFFFFF"/>
-          </a:solidFill>
-          <a:ln w="12700">
-            <a:solidFill>
-              <a:srgbClr val="E2E8F0"/>
-            </a:solidFill>
-          </a:ln>
-        </p:spPr>
-        <p:style>
-          <a:lnRef idx="1">
-            <a:schemeClr val="accent1"/>
-          </a:lnRef>
-          <a:fillRef idx="3">
-            <a:schemeClr val="accent1"/>
-          </a:fillRef>
-          <a:effectRef idx="2">
-            <a:schemeClr val="accent1"/>
-          </a:effectRef>
-          <a:fontRef idx="minor">
-            <a:schemeClr val="lt1"/>
-          </a:fontRef>
-        </p:style>
-        <p:txBody>
-          <a:bodyPr rtlCol="0" anchor="ctr" wrap="square" lIns="228600" tIns="109728" rIns="182880" bIns="91440"/>
-          <a:lstStyle/>
-          <a:p>
-            <a:pPr algn="ctr">
-              <a:defRPr sz="1100" b="1">
-                <a:solidFill>
-                  <a:srgbClr val="0F172A"/>
-                </a:solidFill>
-                <a:latin typeface="Arial"/>
-              </a:defRPr>
-            </a:pPr>
-            <a:r>
-              <a:t>Asynchronous Core API</a:t>
-            </a:r>
-          </a:p>
-          <a:p>
-            <a:pPr>
-              <a:spcBef>
-                <a:spcPts val="200"/>
-              </a:spcBef>
-              <a:defRPr sz="950">
-                <a:solidFill>
-                  <a:srgbClr val="334155"/>
-                </a:solidFill>
-                <a:latin typeface="Arial"/>
-              </a:defRPr>
-            </a:pPr>
-            <a:r>
-              <a:t>FastAPI endpoints handling members, projects, vendors, expenses, and procurement with Pydantic validation.</a:t>
-            </a:r>
-          </a:p>
-        </p:txBody>
-      </p:sp>
-      <p:sp>
-        <p:nvSpPr>
-          <p:cNvPr id="10" name="Rectangle 9"/>
-          <p:cNvSpPr/>
-          <p:nvPr/>
-        </p:nvSpPr>
-        <p:spPr>
-          <a:xfrm>
-            <a:off x="566928" y="4178808"/>
-            <a:ext cx="73152" cy="832104"/>
-          </a:xfrm>
-          <a:prstGeom prst="rect">
-            <a:avLst/>
-          </a:prstGeom>
-          <a:solidFill>
-            <a:srgbClr val="0E7490"/>
-          </a:solidFill>
-          <a:ln>
-            <a:noFill/>
-          </a:ln>
-        </p:spPr>
-        <p:style>
-          <a:lnRef idx="1">
-            <a:schemeClr val="accent1"/>
-          </a:lnRef>
-          <a:fillRef idx="3">
-            <a:schemeClr val="accent1"/>
-          </a:fillRef>
-          <a:effectRef idx="2">
-            <a:schemeClr val="accent1"/>
-          </a:effectRef>
-          <a:fontRef idx="minor">
-            <a:schemeClr val="lt1"/>
-          </a:fontRef>
-        </p:style>
-        <p:txBody>
-          <a:bodyPr rtlCol="0" anchor="ctr"/>
-          <a:lstStyle/>
-          <a:p>
-            <a:pPr algn="ctr"/>
-          </a:p>
-        </p:txBody>
-      </p:sp>
-      <p:sp>
-        <p:nvSpPr>
-          <p:cNvPr id="11" name="Rounded Rectangle 10"/>
-          <p:cNvSpPr/>
-          <p:nvPr/>
-        </p:nvSpPr>
-        <p:spPr>
-          <a:xfrm>
-            <a:off x="548640" y="5257800"/>
-            <a:ext cx="5394960" cy="1051560"/>
-          </a:xfrm>
-          <a:prstGeom prst="roundRect">
-            <a:avLst/>
-          </a:prstGeom>
-          <a:solidFill>
-            <a:srgbClr val="FFFFFF"/>
-          </a:solidFill>
-          <a:ln w="12700">
-            <a:solidFill>
-              <a:srgbClr val="E2E8F0"/>
-            </a:solidFill>
-          </a:ln>
-        </p:spPr>
-        <p:style>
-          <a:lnRef idx="1">
-            <a:schemeClr val="accent1"/>
-          </a:lnRef>
-          <a:fillRef idx="3">
-            <a:schemeClr val="accent1"/>
-          </a:fillRef>
-          <a:effectRef idx="2">
-            <a:schemeClr val="accent1"/>
-          </a:effectRef>
-          <a:fontRef idx="minor">
-            <a:schemeClr val="lt1"/>
-          </a:fontRef>
-        </p:style>
-        <p:txBody>
-          <a:bodyPr rtlCol="0" anchor="ctr" wrap="square" lIns="228600" tIns="109728" rIns="182880" bIns="91440"/>
-          <a:lstStyle/>
-          <a:p>
-            <a:pPr algn="ctr">
-              <a:defRPr sz="1100" b="1">
-                <a:solidFill>
-                  <a:srgbClr val="0F172A"/>
-                </a:solidFill>
-                <a:latin typeface="Arial"/>
-              </a:defRPr>
-            </a:pPr>
-            <a:r>
-              <a:t>Relational Data Integrity</a:t>
-            </a:r>
-          </a:p>
-          <a:p>
-            <a:pPr>
-              <a:spcBef>
-                <a:spcPts val="200"/>
-              </a:spcBef>
-              <a:defRPr sz="950">
-                <a:solidFill>
-                  <a:srgbClr val="334155"/>
-                </a:solidFill>
-                <a:latin typeface="Arial"/>
-              </a:defRPr>
-            </a:pPr>
-            <a:r>
-              <a:t>PostgreSQL schema enforcing strict foreign key constraints across project budgets and purchase orders.</a:t>
-            </a:r>
-          </a:p>
-        </p:txBody>
-      </p:sp>
-      <p:sp>
-        <p:nvSpPr>
-          <p:cNvPr id="12" name="Rectangle 11"/>
-          <p:cNvSpPr/>
-          <p:nvPr/>
-        </p:nvSpPr>
-        <p:spPr>
-          <a:xfrm>
-            <a:off x="566928" y="5367528"/>
-            <a:ext cx="73152" cy="832104"/>
-          </a:xfrm>
-          <a:prstGeom prst="rect">
-            <a:avLst/>
-          </a:prstGeom>
-          <a:solidFill>
-            <a:srgbClr val="0E7490"/>
-          </a:solidFill>
-          <a:ln>
-            <a:noFill/>
-          </a:ln>
-        </p:spPr>
-        <p:style>
-          <a:lnRef idx="1">
-            <a:schemeClr val="accent1"/>
-          </a:lnRef>
-          <a:fillRef idx="3">
-            <a:schemeClr val="accent1"/>
-          </a:fillRef>
-          <a:effectRef idx="2">
-            <a:schemeClr val="accent1"/>
-          </a:effectRef>
-          <a:fontRef idx="minor">
-            <a:schemeClr val="lt1"/>
-          </a:fontRef>
-        </p:style>
-        <p:txBody>
-          <a:bodyPr rtlCol="0" anchor="ctr"/>
-          <a:lstStyle/>
-          <a:p>
-            <a:pPr algn="ctr"/>
-          </a:p>
-        </p:txBody>
-      </p:sp>
-      <p:sp>
-        <p:nvSpPr>
-          <p:cNvPr id="13" name="Rounded Rectangle 12"/>
-          <p:cNvSpPr/>
-          <p:nvPr/>
-        </p:nvSpPr>
-        <p:spPr>
-          <a:xfrm>
-            <a:off x="6172200" y="1691640"/>
-            <a:ext cx="5470855" cy="4617720"/>
+            <a:off x="731520" y="1920240"/>
+            <a:ext cx="5242255" cy="1965960"/>
           </a:xfrm>
           <a:prstGeom prst="roundRect">
             <a:avLst/>
@@ -6239,6 +5987,118 @@
           </a:fontRef>
         </p:style>
         <p:txBody>
+          <a:bodyPr rtlCol="0" anchor="ctr" wrap="square" lIns="274320" tIns="164592" rIns="182880"/>
+          <a:lstStyle/>
+          <a:p>
+            <a:pPr algn="ctr">
+              <a:defRPr sz="1100" b="1">
+                <a:solidFill>
+                  <a:srgbClr val="0E7490"/>
+                </a:solidFill>
+              </a:defRPr>
+            </a:pPr>
+            <a:r>
+              <a:t>STUDENT IDENTIFICATION</a:t>
+            </a:r>
+          </a:p>
+          <a:p>
+            <a:pPr>
+              <a:spcBef>
+                <a:spcPts val="300"/>
+              </a:spcBef>
+              <a:defRPr sz="950">
+                <a:solidFill>
+                  <a:srgbClr val="334155"/>
+                </a:solidFill>
+              </a:defRPr>
+            </a:pPr>
+            <a:r>
+              <a:t>•  Full Name: Sameer Khan S</a:t>
+            </a:r>
+          </a:p>
+          <a:p>
+            <a:pPr>
+              <a:spcBef>
+                <a:spcPts val="300"/>
+              </a:spcBef>
+              <a:defRPr sz="950">
+                <a:solidFill>
+                  <a:srgbClr val="334155"/>
+                </a:solidFill>
+              </a:defRPr>
+            </a:pPr>
+            <a:r>
+              <a:t>•  Roll Number: 24BC10245</a:t>
+            </a:r>
+          </a:p>
+          <a:p>
+            <a:pPr>
+              <a:spcBef>
+                <a:spcPts val="300"/>
+              </a:spcBef>
+              <a:defRPr sz="950">
+                <a:solidFill>
+                  <a:srgbClr val="334155"/>
+                </a:solidFill>
+              </a:defRPr>
+            </a:pPr>
+            <a:r>
+              <a:t>•  Academic Track: DevOps &amp; Cloud Engineering Final Capstone</a:t>
+            </a:r>
+          </a:p>
+          <a:p>
+            <a:pPr>
+              <a:spcBef>
+                <a:spcPts val="300"/>
+              </a:spcBef>
+              <a:defRPr sz="950">
+                <a:solidFill>
+                  <a:srgbClr val="334155"/>
+                </a:solidFill>
+              </a:defRPr>
+            </a:pPr>
+            <a:r>
+              <a:t>•  Evaluation Standard: Session 21 Grading Rubric (100 Points)</a:t>
+            </a:r>
+          </a:p>
+        </p:txBody>
+      </p:sp>
+      <p:sp>
+        <p:nvSpPr>
+          <p:cNvPr id="5" name="Rectangle 4"/>
+          <p:cNvSpPr/>
+          <p:nvPr/>
+        </p:nvSpPr>
+        <p:spPr>
+          <a:xfrm>
+            <a:off x="749808" y="2029968"/>
+            <a:ext cx="73152" cy="1746504"/>
+          </a:xfrm>
+          <a:prstGeom prst="rect">
+            <a:avLst/>
+          </a:prstGeom>
+          <a:solidFill>
+            <a:srgbClr val="0E7490"/>
+          </a:solidFill>
+          <a:ln>
+            <a:noFill/>
+          </a:ln>
+        </p:spPr>
+        <p:style>
+          <a:lnRef idx="1">
+            <a:schemeClr val="accent1"/>
+          </a:lnRef>
+          <a:fillRef idx="3">
+            <a:schemeClr val="accent1"/>
+          </a:fillRef>
+          <a:effectRef idx="2">
+            <a:schemeClr val="accent1"/>
+          </a:effectRef>
+          <a:fontRef idx="minor">
+            <a:schemeClr val="lt1"/>
+          </a:fontRef>
+        </p:style>
+        <p:txBody>
           <a:bodyPr rtlCol="0" anchor="ctr"/>
           <a:lstStyle/>
           <a:p>
@@ -6246,75 +6106,487 @@
           </a:p>
         </p:txBody>
       </p:sp>
-      <p:pic>
-        <p:nvPicPr>
-          <p:cNvPr id="14" name="Picture 13" descr="dashboard.png"/>
-          <p:cNvPicPr>
-            <a:picLocks noChangeAspect="1"/>
-          </p:cNvPicPr>
-          <p:nvPr/>
-        </p:nvPicPr>
-        <p:blipFill>
-          <a:blip r:embed="rId2"/>
-          <a:stretch>
-            <a:fillRect/>
-          </a:stretch>
-        </p:blipFill>
-        <p:spPr>
-          <a:xfrm>
-            <a:off x="6309360" y="2543211"/>
-            <a:ext cx="5196535" cy="2603680"/>
+      <p:sp>
+        <p:nvSpPr>
+          <p:cNvPr id="6" name="Rounded Rectangle 5"/>
+          <p:cNvSpPr/>
+          <p:nvPr/>
+        </p:nvSpPr>
+        <p:spPr>
+          <a:xfrm>
+            <a:off x="6217920" y="1920240"/>
+            <a:ext cx="5242255" cy="1965960"/>
+          </a:xfrm>
+          <a:prstGeom prst="roundRect">
+            <a:avLst/>
+          </a:prstGeom>
+          <a:solidFill>
+            <a:srgbClr val="FFFFFF"/>
+          </a:solidFill>
+          <a:ln w="15240">
+            <a:solidFill>
+              <a:srgbClr val="E2E8F0"/>
+            </a:solidFill>
+          </a:ln>
+        </p:spPr>
+        <p:style>
+          <a:lnRef idx="1">
+            <a:schemeClr val="accent1"/>
+          </a:lnRef>
+          <a:fillRef idx="3">
+            <a:schemeClr val="accent1"/>
+          </a:fillRef>
+          <a:effectRef idx="2">
+            <a:schemeClr val="accent1"/>
+          </a:effectRef>
+          <a:fontRef idx="minor">
+            <a:schemeClr val="lt1"/>
+          </a:fontRef>
+        </p:style>
+        <p:txBody>
+          <a:bodyPr rtlCol="0" anchor="ctr" wrap="square" lIns="274320" tIns="164592" rIns="182880"/>
+          <a:lstStyle/>
+          <a:p>
+            <a:pPr algn="ctr">
+              <a:defRPr sz="1100" b="1">
+                <a:solidFill>
+                  <a:srgbClr val="0E7490"/>
+                </a:solidFill>
+              </a:defRPr>
+            </a:pPr>
+            <a:r>
+              <a:t>PROJECT SPECIFICATIONS</a:t>
+            </a:r>
+          </a:p>
+          <a:p>
+            <a:pPr>
+              <a:spcBef>
+                <a:spcPts val="300"/>
+              </a:spcBef>
+              <a:defRPr sz="950">
+                <a:solidFill>
+                  <a:srgbClr val="334155"/>
+                </a:solidFill>
+              </a:defRPr>
+            </a:pPr>
+            <a:r>
+              <a:t>•  Project Name: Autonomous Robotics Lab Operations Portal</a:t>
+            </a:r>
+          </a:p>
+          <a:p>
+            <a:pPr>
+              <a:spcBef>
+                <a:spcPts val="300"/>
+              </a:spcBef>
+              <a:defRPr sz="950">
+                <a:solidFill>
+                  <a:srgbClr val="334155"/>
+                </a:solidFill>
+              </a:defRPr>
+            </a:pPr>
+            <a:r>
+              <a:t>•  Application Stack: FastAPI (Python 3.12) + React 18 + PostgreSQL 16</a:t>
+            </a:r>
+          </a:p>
+          <a:p>
+            <a:pPr>
+              <a:spcBef>
+                <a:spcPts val="300"/>
+              </a:spcBef>
+              <a:defRPr sz="950">
+                <a:solidFill>
+                  <a:srgbClr val="334155"/>
+                </a:solidFill>
+              </a:defRPr>
+            </a:pPr>
+            <a:r>
+              <a:t>•  Infrastructure Stack: AWS EKS 1.30, Multi-AZ VPC, Terraform, Helm v2</a:t>
+            </a:r>
+          </a:p>
+          <a:p>
+            <a:pPr>
+              <a:spcBef>
+                <a:spcPts val="300"/>
+              </a:spcBef>
+              <a:defRPr sz="950">
+                <a:solidFill>
+                  <a:srgbClr val="334155"/>
+                </a:solidFill>
+              </a:defRPr>
+            </a:pPr>
+            <a:r>
+              <a:t>•  Observability Stack: OpenMetrics, Prometheus Server, Grafana Telemetry</a:t>
+            </a:r>
+          </a:p>
+        </p:txBody>
+      </p:sp>
+      <p:sp>
+        <p:nvSpPr>
+          <p:cNvPr id="7" name="Rectangle 6"/>
+          <p:cNvSpPr/>
+          <p:nvPr/>
+        </p:nvSpPr>
+        <p:spPr>
+          <a:xfrm>
+            <a:off x="6236208" y="2029968"/>
+            <a:ext cx="73152" cy="1746504"/>
           </a:xfrm>
           <a:prstGeom prst="rect">
             <a:avLst/>
           </a:prstGeom>
-        </p:spPr>
-      </p:pic>
-      <p:sp>
-        <p:nvSpPr>
-          <p:cNvPr id="15" name="TextBox 14"/>
+          <a:solidFill>
+            <a:srgbClr val="0E7490"/>
+          </a:solidFill>
+          <a:ln>
+            <a:noFill/>
+          </a:ln>
+        </p:spPr>
+        <p:style>
+          <a:lnRef idx="1">
+            <a:schemeClr val="accent1"/>
+          </a:lnRef>
+          <a:fillRef idx="3">
+            <a:schemeClr val="accent1"/>
+          </a:fillRef>
+          <a:effectRef idx="2">
+            <a:schemeClr val="accent1"/>
+          </a:effectRef>
+          <a:fontRef idx="minor">
+            <a:schemeClr val="lt1"/>
+          </a:fontRef>
+        </p:style>
+        <p:txBody>
+          <a:bodyPr rtlCol="0" anchor="ctr"/>
+          <a:lstStyle/>
+          <a:p>
+            <a:pPr algn="ctr"/>
+          </a:p>
+        </p:txBody>
+      </p:sp>
+      <p:sp>
+        <p:nvSpPr>
+          <p:cNvPr id="8" name="Rounded Rectangle 7"/>
+          <p:cNvSpPr/>
+          <p:nvPr/>
+        </p:nvSpPr>
+        <p:spPr>
+          <a:xfrm>
+            <a:off x="731520" y="4114800"/>
+            <a:ext cx="5242255" cy="1965960"/>
+          </a:xfrm>
+          <a:prstGeom prst="roundRect">
+            <a:avLst/>
+          </a:prstGeom>
+          <a:solidFill>
+            <a:srgbClr val="FFFFFF"/>
+          </a:solidFill>
+          <a:ln w="15240">
+            <a:solidFill>
+              <a:srgbClr val="E2E8F0"/>
+            </a:solidFill>
+          </a:ln>
+        </p:spPr>
+        <p:style>
+          <a:lnRef idx="1">
+            <a:schemeClr val="accent1"/>
+          </a:lnRef>
+          <a:fillRef idx="3">
+            <a:schemeClr val="accent1"/>
+          </a:fillRef>
+          <a:effectRef idx="2">
+            <a:schemeClr val="accent1"/>
+          </a:effectRef>
+          <a:fontRef idx="minor">
+            <a:schemeClr val="lt1"/>
+          </a:fontRef>
+        </p:style>
+        <p:txBody>
+          <a:bodyPr rtlCol="0" anchor="ctr" wrap="square" lIns="274320" tIns="164592" rIns="182880"/>
+          <a:lstStyle/>
+          <a:p>
+            <a:pPr algn="ctr">
+              <a:defRPr sz="1100" b="1">
+                <a:solidFill>
+                  <a:srgbClr val="0E7490"/>
+                </a:solidFill>
+              </a:defRPr>
+            </a:pPr>
+            <a:r>
+              <a:t>EVALUATION &amp; QUALITY METRICS</a:t>
+            </a:r>
+          </a:p>
+          <a:p>
+            <a:pPr>
+              <a:spcBef>
+                <a:spcPts val="300"/>
+              </a:spcBef>
+              <a:defRPr sz="950">
+                <a:solidFill>
+                  <a:srgbClr val="334155"/>
+                </a:solidFill>
+              </a:defRPr>
+            </a:pPr>
+            <a:r>
+              <a:t>•  Automated Testing: 10 Passed Pytest Test Cases (0 Failures)</a:t>
+            </a:r>
+          </a:p>
+          <a:p>
+            <a:pPr>
+              <a:spcBef>
+                <a:spcPts val="300"/>
+              </a:spcBef>
+              <a:defRPr sz="950">
+                <a:solidFill>
+                  <a:srgbClr val="334155"/>
+                </a:solidFill>
+              </a:defRPr>
+            </a:pPr>
+            <a:r>
+              <a:t>•  Security Hardening: 0 Unfixed High/Critical CVEs via Aqua Trivy</a:t>
+            </a:r>
+          </a:p>
+          <a:p>
+            <a:pPr>
+              <a:spcBef>
+                <a:spcPts val="300"/>
+              </a:spcBef>
+              <a:defRPr sz="950">
+                <a:solidFill>
+                  <a:srgbClr val="334155"/>
+                </a:solidFill>
+              </a:defRPr>
+            </a:pPr>
+            <a:r>
+              <a:t>•  Docker Optimization: 60MB Hardened Non-Root Alpine Containers</a:t>
+            </a:r>
+          </a:p>
+          <a:p>
+            <a:pPr>
+              <a:spcBef>
+                <a:spcPts val="300"/>
+              </a:spcBef>
+              <a:defRPr sz="950">
+                <a:solidFill>
+                  <a:srgbClr val="334155"/>
+                </a:solidFill>
+              </a:defRPr>
+            </a:pPr>
+            <a:r>
+              <a:t>•  CI/CD Automation: 100% Green GitHub Actions Pipeline Execution</a:t>
+            </a:r>
+          </a:p>
+        </p:txBody>
+      </p:sp>
+      <p:sp>
+        <p:nvSpPr>
+          <p:cNvPr id="9" name="Rectangle 8"/>
+          <p:cNvSpPr/>
+          <p:nvPr/>
+        </p:nvSpPr>
+        <p:spPr>
+          <a:xfrm>
+            <a:off x="749808" y="4224528"/>
+            <a:ext cx="73152" cy="1746504"/>
+          </a:xfrm>
+          <a:prstGeom prst="rect">
+            <a:avLst/>
+          </a:prstGeom>
+          <a:solidFill>
+            <a:srgbClr val="0E7490"/>
+          </a:solidFill>
+          <a:ln>
+            <a:noFill/>
+          </a:ln>
+        </p:spPr>
+        <p:style>
+          <a:lnRef idx="1">
+            <a:schemeClr val="accent1"/>
+          </a:lnRef>
+          <a:fillRef idx="3">
+            <a:schemeClr val="accent1"/>
+          </a:fillRef>
+          <a:effectRef idx="2">
+            <a:schemeClr val="accent1"/>
+          </a:effectRef>
+          <a:fontRef idx="minor">
+            <a:schemeClr val="lt1"/>
+          </a:fontRef>
+        </p:style>
+        <p:txBody>
+          <a:bodyPr rtlCol="0" anchor="ctr"/>
+          <a:lstStyle/>
+          <a:p>
+            <a:pPr algn="ctr"/>
+          </a:p>
+        </p:txBody>
+      </p:sp>
+      <p:sp>
+        <p:nvSpPr>
+          <p:cNvPr id="10" name="Rounded Rectangle 9"/>
+          <p:cNvSpPr/>
+          <p:nvPr/>
+        </p:nvSpPr>
+        <p:spPr>
+          <a:xfrm>
+            <a:off x="6217920" y="4114800"/>
+            <a:ext cx="5242255" cy="1965960"/>
+          </a:xfrm>
+          <a:prstGeom prst="roundRect">
+            <a:avLst/>
+          </a:prstGeom>
+          <a:solidFill>
+            <a:srgbClr val="FFFFFF"/>
+          </a:solidFill>
+          <a:ln w="15240">
+            <a:solidFill>
+              <a:srgbClr val="E2E8F0"/>
+            </a:solidFill>
+          </a:ln>
+        </p:spPr>
+        <p:style>
+          <a:lnRef idx="1">
+            <a:schemeClr val="accent1"/>
+          </a:lnRef>
+          <a:fillRef idx="3">
+            <a:schemeClr val="accent1"/>
+          </a:fillRef>
+          <a:effectRef idx="2">
+            <a:schemeClr val="accent1"/>
+          </a:effectRef>
+          <a:fontRef idx="minor">
+            <a:schemeClr val="lt1"/>
+          </a:fontRef>
+        </p:style>
+        <p:txBody>
+          <a:bodyPr rtlCol="0" anchor="ctr" wrap="square" lIns="274320" tIns="164592" rIns="182880"/>
+          <a:lstStyle/>
+          <a:p>
+            <a:pPr algn="ctr">
+              <a:defRPr sz="1100" b="1">
+                <a:solidFill>
+                  <a:srgbClr val="0E7490"/>
+                </a:solidFill>
+              </a:defRPr>
+            </a:pPr>
+            <a:r>
+              <a:t>SUBMISSION &amp; REPOSITORY ASSETS</a:t>
+            </a:r>
+          </a:p>
+          <a:p>
+            <a:pPr>
+              <a:spcBef>
+                <a:spcPts val="300"/>
+              </a:spcBef>
+              <a:defRPr sz="950">
+                <a:solidFill>
+                  <a:srgbClr val="334155"/>
+                </a:solidFill>
+              </a:defRPr>
+            </a:pPr>
+            <a:r>
+              <a:t>•  GitHub Repository: github.com/SameerKhans13/devops-robotics-portal</a:t>
+            </a:r>
+          </a:p>
+          <a:p>
+            <a:pPr>
+              <a:spcBef>
+                <a:spcPts val="300"/>
+              </a:spcBef>
+              <a:defRPr sz="950">
+                <a:solidFill>
+                  <a:srgbClr val="334155"/>
+                </a:solidFill>
+              </a:defRPr>
+            </a:pPr>
+            <a:r>
+              <a:t>•  Active Branch: main (Protected with Automated Status Checks)</a:t>
+            </a:r>
+          </a:p>
+          <a:p>
+            <a:pPr>
+              <a:spcBef>
+                <a:spcPts val="300"/>
+              </a:spcBef>
+              <a:defRPr sz="950">
+                <a:solidFill>
+                  <a:srgbClr val="334155"/>
+                </a:solidFill>
+              </a:defRPr>
+            </a:pPr>
+            <a:r>
+              <a:t>•  Documentation: PROJECT_REPORT.md, README.md, presentation.html</a:t>
+            </a:r>
+          </a:p>
+          <a:p>
+            <a:pPr>
+              <a:spcBef>
+                <a:spcPts val="300"/>
+              </a:spcBef>
+              <a:defRPr sz="950">
+                <a:solidFill>
+                  <a:srgbClr val="334155"/>
+                </a:solidFill>
+              </a:defRPr>
+            </a:pPr>
+            <a:r>
+              <a:t>•  Presentation Deck: robotics_portal_devops_presentation.pptx (16:9)</a:t>
+            </a:r>
+          </a:p>
+        </p:txBody>
+      </p:sp>
+      <p:sp>
+        <p:nvSpPr>
+          <p:cNvPr id="11" name="Rectangle 10"/>
+          <p:cNvSpPr/>
+          <p:nvPr/>
+        </p:nvSpPr>
+        <p:spPr>
+          <a:xfrm>
+            <a:off x="6236208" y="4224528"/>
+            <a:ext cx="73152" cy="1746504"/>
+          </a:xfrm>
+          <a:prstGeom prst="rect">
+            <a:avLst/>
+          </a:prstGeom>
+          <a:solidFill>
+            <a:srgbClr val="0E7490"/>
+          </a:solidFill>
+          <a:ln>
+            <a:noFill/>
+          </a:ln>
+        </p:spPr>
+        <p:style>
+          <a:lnRef idx="1">
+            <a:schemeClr val="accent1"/>
+          </a:lnRef>
+          <a:fillRef idx="3">
+            <a:schemeClr val="accent1"/>
+          </a:fillRef>
+          <a:effectRef idx="2">
+            <a:schemeClr val="accent1"/>
+          </a:effectRef>
+          <a:fontRef idx="minor">
+            <a:schemeClr val="lt1"/>
+          </a:fontRef>
+        </p:style>
+        <p:txBody>
+          <a:bodyPr rtlCol="0" anchor="ctr"/>
+          <a:lstStyle/>
+          <a:p>
+            <a:pPr algn="ctr"/>
+          </a:p>
+        </p:txBody>
+      </p:sp>
+      <p:sp>
+        <p:nvSpPr>
+          <p:cNvPr id="12" name="TextBox 11"/>
           <p:cNvSpPr txBox="1"/>
           <p:nvPr/>
         </p:nvSpPr>
         <p:spPr>
           <a:xfrm>
-            <a:off x="6355080" y="5806440"/>
-            <a:ext cx="5105095" cy="411480"/>
-          </a:xfrm>
-          <a:prstGeom prst="rect">
-            <a:avLst/>
-          </a:prstGeom>
-          <a:noFill/>
-        </p:spPr>
-        <p:txBody>
-          <a:bodyPr wrap="square">
-            <a:spAutoFit/>
-          </a:bodyPr>
-          <a:lstStyle/>
-          <a:p>
-            <a:pPr algn="ctr">
-              <a:defRPr sz="850">
-                <a:solidFill>
-                  <a:srgbClr val="64748B"/>
-                </a:solidFill>
-              </a:defRPr>
-            </a:pPr>
-            <a:r>
-              <a:t>📷  Laboratory Light Theme with active hardware telemetry and budget status.</a:t>
-            </a:r>
-          </a:p>
-        </p:txBody>
-      </p:sp>
-      <p:sp>
-        <p:nvSpPr>
-          <p:cNvPr id="16" name="TextBox 15"/>
-          <p:cNvSpPr txBox="1"/>
-          <p:nvPr/>
-        </p:nvSpPr>
-        <p:spPr>
-          <a:xfrm>
-            <a:off x="548640" y="6400800"/>
-            <a:ext cx="11094415" cy="320040"/>
+            <a:off x="731520" y="6263640"/>
+            <a:ext cx="10728655" cy="365760"/>
           </a:xfrm>
           <a:prstGeom prst="rect">
             <a:avLst/>
@@ -6335,7 +6607,7 @@
               </a:defRPr>
             </a:pPr>
             <a:r>
-              <a:t>Autonomous Robotics Lab Operations Portal  |  Presenter: Sameer Khan  |  Slide 2 of 11</a:t>
+              <a:t>Candidate: Sameer Khan S  |  Roll Number: 24BC10245  |  Autonomous Robotics Lab Portal  |  Slide 2 of 12</a:t>
             </a:r>
           </a:p>
         </p:txBody>
@@ -6451,7 +6723,7 @@
               </a:defRPr>
             </a:pPr>
             <a:r>
-              <a:t>MODULE 2 — AUTOMATED TESTING &amp; CODE QUALITY</a:t>
+              <a:t>MODULE 1 — APPLICATION &amp; DATABASE ARCHITECTURE</a:t>
             </a:r>
           </a:p>
           <a:p>
@@ -6464,7 +6736,7 @@
               </a:defRPr>
             </a:pPr>
             <a:r>
-              <a:t>Interactive Forms &amp; 100% Pytest Pass Rate</a:t>
+              <a:t>High-Contrast Laboratory UI &amp; Relational Backend</a:t>
             </a:r>
           </a:p>
           <a:p>
@@ -6477,7 +6749,7 @@
               </a:defRPr>
             </a:pPr>
             <a:r>
-              <a:t>Dynamic payload validation paired with isolated SQLite in-memory test fixtures</a:t>
+              <a:t>Engineered for high-illumination robotics laboratory environments with real-time hardware telemetry</a:t>
             </a:r>
           </a:p>
         </p:txBody>
@@ -6531,7 +6803,7 @@
               </a:defRPr>
             </a:pPr>
             <a:r>
-              <a:t>TEST RESULTS</a:t>
+              <a:t>DATABASE ENTITIES</a:t>
             </a:r>
           </a:p>
           <a:p>
@@ -6543,7 +6815,7 @@
               </a:defRPr>
             </a:pPr>
             <a:r>
-              <a:t>10 / 10 PASSED</a:t>
+              <a:t>6 Tables</a:t>
             </a:r>
           </a:p>
           <a:p>
@@ -6555,7 +6827,7 @@
               </a:defRPr>
             </a:pPr>
             <a:r>
-              <a:t>Execution Time: 2.61s (0 Failures)</a:t>
+              <a:t>Alembic Versioned Migrations</a:t>
             </a:r>
           </a:p>
         </p:txBody>
@@ -6610,7 +6882,7 @@
               </a:defRPr>
             </a:pPr>
             <a:r>
-              <a:t>Interactive Modal Dialog</a:t>
+              <a:t>Laboratory Light Interface</a:t>
             </a:r>
           </a:p>
           <a:p>
@@ -6626,7 +6898,7 @@
               </a:defRPr>
             </a:pPr>
             <a:r>
-              <a:t>Client-side date normalization, boundary checks, and budget allocation error handling.</a:t>
+              <a:t>Crisp, accessible UI styled with Tailwind CSS, custom robotics SVGs, and responsive hardware cards.</a:t>
             </a:r>
           </a:p>
         </p:txBody>
@@ -6724,7 +6996,7 @@
               </a:defRPr>
             </a:pPr>
             <a:r>
-              <a:t>Zero Production Pollution</a:t>
+              <a:t>Active Robotics Telemetry</a:t>
             </a:r>
           </a:p>
           <a:p>
@@ -6740,7 +7012,7 @@
               </a:defRPr>
             </a:pPr>
             <a:r>
-              <a:t>Pytest suite leverages in-memory SQLite fixtures with automated teardown per test function.</a:t>
+              <a:t>Live battery indicators and mission tracking for Titan-X Quadruped, Nautilus ROV, and AeroGlide Drone.</a:t>
             </a:r>
           </a:p>
         </p:txBody>
@@ -6838,7 +7110,7 @@
               </a:defRPr>
             </a:pPr>
             <a:r>
-              <a:t>Comprehensive Coverage</a:t>
+              <a:t>Asynchronous Core API</a:t>
             </a:r>
           </a:p>
           <a:p>
@@ -6854,7 +7126,7 @@
               </a:defRPr>
             </a:pPr>
             <a:r>
-              <a:t>Validates health probes, CRUD operations, unique purchase order numbers, and dashboard aggregations.</a:t>
+              <a:t>FastAPI endpoints handling members, projects, vendors, expenses, and procurement with Pydantic validation.</a:t>
             </a:r>
           </a:p>
         </p:txBody>
@@ -6952,7 +7224,7 @@
               </a:defRPr>
             </a:pPr>
             <a:r>
-              <a:t>Strict CI Quality Gate</a:t>
+              <a:t>Relational Data Integrity</a:t>
             </a:r>
           </a:p>
           <a:p>
@@ -6968,7 +7240,7 @@
               </a:defRPr>
             </a:pPr>
             <a:r>
-              <a:t>GitHub Actions pipeline immediately terminates on any single test failure before building images.</a:t>
+              <a:t>PostgreSQL schema enforcing strict foreign key constraints across project budgets and purchase orders.</a:t>
             </a:r>
           </a:p>
         </p:txBody>
@@ -7063,7 +7335,7 @@
       </p:sp>
       <p:pic>
         <p:nvPicPr>
-          <p:cNvPr id="14" name="Picture 13" descr="new_project_modal.png"/>
+          <p:cNvPr id="14" name="Picture 13" descr="dashboard.png"/>
           <p:cNvPicPr>
             <a:picLocks noChangeAspect="1"/>
           </p:cNvPicPr>
@@ -7115,7 +7387,7 @@
               </a:defRPr>
             </a:pPr>
             <a:r>
-              <a:t>📷  Interactive Project Creation Modal with live form validation and date formatting.</a:t>
+              <a:t>📷  Laboratory Light Theme with active hardware telemetry and budget status.</a:t>
             </a:r>
           </a:p>
         </p:txBody>
@@ -7150,7 +7422,7 @@
               </a:defRPr>
             </a:pPr>
             <a:r>
-              <a:t>Autonomous Robotics Lab Operations Portal  |  Presenter: Sameer Khan  |  Slide 3 of 11</a:t>
+              <a:t>Autonomous Robotics Lab Operations Portal  |  Sameer Khan S (24BC10245)  |  Slide 3 of 12</a:t>
             </a:r>
           </a:p>
         </p:txBody>
@@ -7266,7 +7538,7 @@
               </a:defRPr>
             </a:pPr>
             <a:r>
-              <a:t>MODULE 4 — CONTAINERIZATION &amp; MULTI-STAGE BUILDS</a:t>
+              <a:t>MODULE 2 — AUTOMATED TESTING &amp; CODE QUALITY</a:t>
             </a:r>
           </a:p>
           <a:p>
@@ -7279,7 +7551,7 @@
               </a:defRPr>
             </a:pPr>
             <a:r>
-              <a:t>Hardened Non-Root Alpine Containers &amp; Compose</a:t>
+              <a:t>Interactive Forms &amp; 100% Pytest Pass Rate</a:t>
             </a:r>
           </a:p>
           <a:p>
@@ -7292,7 +7564,7 @@
               </a:defRPr>
             </a:pPr>
             <a:r>
-              <a:t>Lightweight OCI container architecture running locally with single-command orchestration</a:t>
+              <a:t>Dynamic payload validation paired with isolated SQLite in-memory test fixtures</a:t>
             </a:r>
           </a:p>
         </p:txBody>
@@ -7346,7 +7618,7 @@
               </a:defRPr>
             </a:pPr>
             <a:r>
-              <a:t>BACKEND SIZE</a:t>
+              <a:t>TEST RESULTS</a:t>
             </a:r>
           </a:p>
           <a:p>
@@ -7358,7 +7630,7 @@
               </a:defRPr>
             </a:pPr>
             <a:r>
-              <a:t>60 MB</a:t>
+              <a:t>10 / 10 PASSED</a:t>
             </a:r>
           </a:p>
           <a:p>
@@ -7370,7 +7642,7 @@
               </a:defRPr>
             </a:pPr>
             <a:r>
-              <a:t>Compacted from 180MB Debian</a:t>
+              <a:t>Execution Time: 2.61s (0 Failures)</a:t>
             </a:r>
           </a:p>
         </p:txBody>
@@ -7425,7 +7697,7 @@
               </a:defRPr>
             </a:pPr>
             <a:r>
-              <a:t>Multi-Stage Frontend Build</a:t>
+              <a:t>Interactive Modal Dialog</a:t>
             </a:r>
           </a:p>
           <a:p>
@@ -7441,7 +7713,7 @@
               </a:defRPr>
             </a:pPr>
             <a:r>
-              <a:t>Node 20 Alpine compilation stage produces optimized static assets served by unprivileged Nginx runtime.</a:t>
+              <a:t>Client-side date normalization, boundary checks, and budget allocation error handling.</a:t>
             </a:r>
           </a:p>
         </p:txBody>
@@ -7539,7 +7811,7 @@
               </a:defRPr>
             </a:pPr>
             <a:r>
-              <a:t>Hardened Alpine Backend</a:t>
+              <a:t>Zero Production Pollution</a:t>
             </a:r>
           </a:p>
           <a:p>
@@ -7555,7 +7827,7 @@
               </a:defRPr>
             </a:pPr>
             <a:r>
-              <a:t>Python 3.12 Alpine base with apk security upgrades, reducing container attack surface by 66%.</a:t>
+              <a:t>Pytest suite leverages in-memory SQLite fixtures with automated teardown per test function.</a:t>
             </a:r>
           </a:p>
         </p:txBody>
@@ -7653,7 +7925,7 @@
               </a:defRPr>
             </a:pPr>
             <a:r>
-              <a:t>Non-Root Security Model</a:t>
+              <a:t>Comprehensive Coverage</a:t>
             </a:r>
           </a:p>
           <a:p>
@@ -7669,7 +7941,7 @@
               </a:defRPr>
             </a:pPr>
             <a:r>
-              <a:t>Containers execute under unprivileged user appuser (UID 10001) preventing privilege escalation.</a:t>
+              <a:t>Validates health probes, CRUD operations, unique purchase order numbers, and dashboard aggregations.</a:t>
             </a:r>
           </a:p>
         </p:txBody>
@@ -7767,7 +8039,7 @@
               </a:defRPr>
             </a:pPr>
             <a:r>
-              <a:t>Unified Docker Compose</a:t>
+              <a:t>Strict CI Quality Gate</a:t>
             </a:r>
           </a:p>
           <a:p>
@@ -7783,7 +8055,7 @@
               </a:defRPr>
             </a:pPr>
             <a:r>
-              <a:t>Orchestrates frontend, backend, PostgreSQL, Prometheus, and Grafana with ordered health checks.</a:t>
+              <a:t>GitHub Actions pipeline immediately terminates on any single test failure before building images.</a:t>
             </a:r>
           </a:p>
         </p:txBody>
@@ -7878,7 +8150,7 @@
       </p:sp>
       <p:pic>
         <p:nvPicPr>
-          <p:cNvPr id="14" name="Picture 13" descr="docker.png"/>
+          <p:cNvPr id="14" name="Picture 13" descr="new_project_modal.png"/>
           <p:cNvPicPr>
             <a:picLocks noChangeAspect="1"/>
           </p:cNvPicPr>
@@ -7892,8 +8164,8 @@
         </p:blipFill>
         <p:spPr>
           <a:xfrm>
-            <a:off x="6309360" y="3055256"/>
-            <a:ext cx="5196535" cy="1579591"/>
+            <a:off x="6309360" y="2543211"/>
+            <a:ext cx="5196535" cy="2603680"/>
           </a:xfrm>
           <a:prstGeom prst="rect">
             <a:avLst/>
@@ -7930,7 +8202,7 @@
               </a:defRPr>
             </a:pPr>
             <a:r>
-              <a:t>📷  Active Docker Compose runtime showing healthy service endpoints and databases.</a:t>
+              <a:t>📷  Interactive Project Creation Modal with live form validation and date formatting.</a:t>
             </a:r>
           </a:p>
         </p:txBody>
@@ -7965,7 +8237,7 @@
               </a:defRPr>
             </a:pPr>
             <a:r>
-              <a:t>Autonomous Robotics Lab Operations Portal  |  Presenter: Sameer Khan  |  Slide 4 of 11</a:t>
+              <a:t>Autonomous Robotics Lab Operations Portal  |  Sameer Khan S (24BC10245)  |  Slide 4 of 12</a:t>
             </a:r>
           </a:p>
         </p:txBody>
@@ -8081,7 +8353,7 @@
               </a:defRPr>
             </a:pPr>
             <a:r>
-              <a:t>MODULE 5 — CONTINUOUS INTEGRATION &amp; DELIVERY</a:t>
+              <a:t>MODULE 4 — CONTAINERIZATION &amp; MULTI-STAGE BUILDS</a:t>
             </a:r>
           </a:p>
           <a:p>
@@ -8094,7 +8366,7 @@
               </a:defRPr>
             </a:pPr>
             <a:r>
-              <a:t>Automated GitHub Actions CI/CD Pipeline</a:t>
+              <a:t>Hardened Non-Root Alpine Containers &amp; Compose</a:t>
             </a:r>
           </a:p>
           <a:p>
@@ -8107,7 +8379,7 @@
               </a:defRPr>
             </a:pPr>
             <a:r>
-              <a:t>Deterministic automation pipeline executing on every push or pull request to main</a:t>
+              <a:t>Lightweight OCI container architecture running locally with single-command orchestration</a:t>
             </a:r>
           </a:p>
         </p:txBody>
@@ -8161,7 +8433,7 @@
               </a:defRPr>
             </a:pPr>
             <a:r>
-              <a:t>PIPELINE RUN</a:t>
+              <a:t>BACKEND SIZE</a:t>
             </a:r>
           </a:p>
           <a:p>
@@ -8173,7 +8445,7 @@
               </a:defRPr>
             </a:pPr>
             <a:r>
-              <a:t>100% GREEN</a:t>
+              <a:t>60 MB</a:t>
             </a:r>
           </a:p>
           <a:p>
@@ -8185,7 +8457,7 @@
               </a:defRPr>
             </a:pPr>
             <a:r>
-              <a:t>Build Time: 2m 15s across 4 Jobs</a:t>
+              <a:t>Compacted from 180MB Debian</a:t>
             </a:r>
           </a:p>
         </p:txBody>
@@ -8240,7 +8512,7 @@
               </a:defRPr>
             </a:pPr>
             <a:r>
-              <a:t>Parallel Quality Testing</a:t>
+              <a:t>Multi-Stage Frontend Build</a:t>
             </a:r>
           </a:p>
           <a:p>
@@ -8256,7 +8528,7 @@
               </a:defRPr>
             </a:pPr>
             <a:r>
-              <a:t>Concurrent execution of Pytest test suite in Python 3.12 and Vite frontend asset compilation in Node 20.</a:t>
+              <a:t>Node 20 Alpine compilation stage produces optimized static assets served by unprivileged Nginx runtime.</a:t>
             </a:r>
           </a:p>
         </p:txBody>
@@ -8354,7 +8626,7 @@
               </a:defRPr>
             </a:pPr>
             <a:r>
-              <a:t>Docker Buildx &amp; Layer Caching</a:t>
+              <a:t>Hardened Alpine Backend</a:t>
             </a:r>
           </a:p>
           <a:p>
@@ -8370,7 +8642,7 @@
               </a:defRPr>
             </a:pPr>
             <a:r>
-              <a:t>Leverages GitHub Actions cache (type=gha, mode=max) delivering 3x faster subsequent builds.</a:t>
+              <a:t>Python 3.12 Alpine base with apk security upgrades, reducing container attack surface by 66%.</a:t>
             </a:r>
           </a:p>
         </p:txBody>
@@ -8468,7 +8740,7 @@
               </a:defRPr>
             </a:pPr>
             <a:r>
-              <a:t>Immutable GHCR Publishing</a:t>
+              <a:t>Non-Root Security Model</a:t>
             </a:r>
           </a:p>
           <a:p>
@@ -8484,7 +8756,7 @@
               </a:defRPr>
             </a:pPr>
             <a:r>
-              <a:t>Images published to GitHub Container Registry tagged with unique 7-character Git commit SHAs.</a:t>
+              <a:t>Containers execute under unprivileged user appuser (UID 10001) preventing privilege escalation.</a:t>
             </a:r>
           </a:p>
         </p:txBody>
@@ -8582,7 +8854,7 @@
               </a:defRPr>
             </a:pPr>
             <a:r>
-              <a:t>Automated Security Trigger</a:t>
+              <a:t>Unified Docker Compose</a:t>
             </a:r>
           </a:p>
           <a:p>
@@ -8598,7 +8870,7 @@
               </a:defRPr>
             </a:pPr>
             <a:r>
-              <a:t>Successful container publication immediately triggers the downstream Trivy vulnerability scan.</a:t>
+              <a:t>Orchestrates frontend, backend, PostgreSQL, Prometheus, and Grafana with ordered health checks.</a:t>
             </a:r>
           </a:p>
         </p:txBody>
@@ -8693,7 +8965,7 @@
       </p:sp>
       <p:pic>
         <p:nvPicPr>
-          <p:cNvPr id="14" name="Picture 13" descr="github-ci-cd-pip.png"/>
+          <p:cNvPr id="14" name="Picture 13" descr="docker.png"/>
           <p:cNvPicPr>
             <a:picLocks noChangeAspect="1"/>
           </p:cNvPicPr>
@@ -8707,8 +8979,8 @@
         </p:blipFill>
         <p:spPr>
           <a:xfrm>
-            <a:off x="6309360" y="2394658"/>
-            <a:ext cx="5196535" cy="2900786"/>
+            <a:off x="6309360" y="3055256"/>
+            <a:ext cx="5196535" cy="1579591"/>
           </a:xfrm>
           <a:prstGeom prst="rect">
             <a:avLst/>
@@ -8745,7 +9017,7 @@
               </a:defRPr>
             </a:pPr>
             <a:r>
-              <a:t>📷  GitHub Actions workflow run: Frontend Build, Pytest, Docker Buildx, and Trivy all green.</a:t>
+              <a:t>📷  Active Docker Compose runtime showing healthy service endpoints and databases.</a:t>
             </a:r>
           </a:p>
         </p:txBody>
@@ -8780,7 +9052,7 @@
               </a:defRPr>
             </a:pPr>
             <a:r>
-              <a:t>Autonomous Robotics Lab Operations Portal  |  Presenter: Sameer Khan  |  Slide 5 of 11</a:t>
+              <a:t>Autonomous Robotics Lab Operations Portal  |  Sameer Khan S (24BC10245)  |  Slide 5 of 12</a:t>
             </a:r>
           </a:p>
         </p:txBody>
@@ -8896,7 +9168,7 @@
               </a:defRPr>
             </a:pPr>
             <a:r>
-              <a:t>MODULE 6 — DEVSECOPS &amp; TRIVY VULNERABILITY SCAN</a:t>
+              <a:t>MODULE 5 — CONTINUOUS INTEGRATION &amp; DELIVERY</a:t>
             </a:r>
           </a:p>
           <a:p>
@@ -8909,7 +9181,7 @@
               </a:defRPr>
             </a:pPr>
             <a:r>
-              <a:t>Continuous Container Auditing &amp; Zero-CVE Gate</a:t>
+              <a:t>Automated GitHub Actions CI/CD Pipeline</a:t>
             </a:r>
           </a:p>
           <a:p>
@@ -8922,7 +9194,7 @@
               </a:defRPr>
             </a:pPr>
             <a:r>
-              <a:t>Enforcing automated security scans with zero tolerated High or Critical vulnerabilities</a:t>
+              <a:t>Deterministic automation pipeline executing on every push or pull request to main</a:t>
             </a:r>
           </a:p>
         </p:txBody>
@@ -8976,7 +9248,7 @@
               </a:defRPr>
             </a:pPr>
             <a:r>
-              <a:t>HIGH / CRIT CVEs</a:t>
+              <a:t>PIPELINE RUN</a:t>
             </a:r>
           </a:p>
           <a:p>
@@ -8988,7 +9260,7 @@
               </a:defRPr>
             </a:pPr>
             <a:r>
-              <a:t>0 BLOCKERS</a:t>
+              <a:t>100% GREEN</a:t>
             </a:r>
           </a:p>
           <a:p>
@@ -9000,7 +9272,7 @@
               </a:defRPr>
             </a:pPr>
             <a:r>
-              <a:t>Exit-Code 1 Security Policy Enforced</a:t>
+              <a:t>Build Time: 2m 15s across 4 Jobs</a:t>
             </a:r>
           </a:p>
         </p:txBody>
@@ -9055,7 +9327,7 @@
               </a:defRPr>
             </a:pPr>
             <a:r>
-              <a:t>Automated Security Gate</a:t>
+              <a:t>Parallel Quality Testing</a:t>
             </a:r>
           </a:p>
           <a:p>
@@ -9071,7 +9343,7 @@
               </a:defRPr>
             </a:pPr>
             <a:r>
-              <a:t>Aqua Security Trivy analyzes backend and frontend container filesystems directly in the CI runner.</a:t>
+              <a:t>Concurrent execution of Pytest test suite in Python 3.12 and Vite frontend asset compilation in Node 20.</a:t>
             </a:r>
           </a:p>
         </p:txBody>
@@ -9169,7 +9441,7 @@
               </a:defRPr>
             </a:pPr>
             <a:r>
-              <a:t>Debian CVE Elimination</a:t>
+              <a:t>Docker Buildx &amp; Layer Caching</a:t>
             </a:r>
           </a:p>
           <a:p>
@@ -9185,7 +9457,7 @@
               </a:defRPr>
             </a:pPr>
             <a:r>
-              <a:t>Replaced Debian Slim base (48 high CVEs in util-linux/systemd) with clean, upgraded Alpine Linux.</a:t>
+              <a:t>Leverages GitHub Actions cache (type=gha, mode=max) delivering 3x faster subsequent builds.</a:t>
             </a:r>
           </a:p>
         </p:txBody>
@@ -9283,7 +9555,7 @@
               </a:defRPr>
             </a:pPr>
             <a:r>
-              <a:t>Patched Dependencies</a:t>
+              <a:t>Immutable GHCR Publishing</a:t>
             </a:r>
           </a:p>
           <a:p>
@@ -9299,7 +9571,7 @@
               </a:defRPr>
             </a:pPr>
             <a:r>
-              <a:t>Updated python-multipart to &gt;=0.0.30 to remediate CVE-2026-24486, CVE-2026-42561, &amp; CVE-2026-53539.</a:t>
+              <a:t>Images published to GitHub Container Registry tagged with unique 7-character Git commit SHAs.</a:t>
             </a:r>
           </a:p>
         </p:txBody>
@@ -9397,7 +9669,7 @@
               </a:defRPr>
             </a:pPr>
             <a:r>
-              <a:t>FastAPI 0.137+ Compatibility</a:t>
+              <a:t>Automated Security Trigger</a:t>
             </a:r>
           </a:p>
           <a:p>
@@ -9413,7 +9685,7 @@
               </a:defRPr>
             </a:pPr>
             <a:r>
-              <a:t>Pinned FastAPI &lt;0.137.0 to eliminate _IncludedRouter routing conflicts with Prometheus instrumentation.</a:t>
+              <a:t>Successful container publication immediately triggers the downstream Trivy vulnerability scan.</a:t>
             </a:r>
           </a:p>
         </p:txBody>
@@ -9560,7 +9832,7 @@
               </a:defRPr>
             </a:pPr>
             <a:r>
-              <a:t>📷  Trivy Security Gate passing cleanly with zero unfixed High/Critical vulnerabilities.</a:t>
+              <a:t>📷  GitHub Actions workflow run: Frontend Build, Pytest, Docker Buildx, and Trivy all green.</a:t>
             </a:r>
           </a:p>
         </p:txBody>
@@ -9595,7 +9867,7 @@
               </a:defRPr>
             </a:pPr>
             <a:r>
-              <a:t>Autonomous Robotics Lab Operations Portal  |  Presenter: Sameer Khan  |  Slide 6 of 11</a:t>
+              <a:t>Autonomous Robotics Lab Operations Portal  |  Sameer Khan S (24BC10245)  |  Slide 6 of 12</a:t>
             </a:r>
           </a:p>
         </p:txBody>
@@ -9711,7 +9983,7 @@
               </a:defRPr>
             </a:pPr>
             <a:r>
-              <a:t>MODULE 7 — INFRASTRUCTURE AS CODE (TERRAFORM)</a:t>
+              <a:t>MODULE 6 — DEVSECOPS &amp; TRIVY VULNERABILITY SCAN</a:t>
             </a:r>
           </a:p>
           <a:p>
@@ -9724,7 +9996,7 @@
               </a:defRPr>
             </a:pPr>
             <a:r>
-              <a:t>AWS Multi-AZ VPC &amp; EKS Cluster Provisioning</a:t>
+              <a:t>Continuous Container Auditing &amp; Zero-CVE Gate</a:t>
             </a:r>
           </a:p>
           <a:p>
@@ -9737,7 +10009,7 @@
               </a:defRPr>
             </a:pPr>
             <a:r>
-              <a:t>Declarative cloud infrastructure provisioning 15 AWS resources across multiple availability zones</a:t>
+              <a:t>Enforcing automated security scans with zero tolerated High or Critical vulnerabilities</a:t>
             </a:r>
           </a:p>
         </p:txBody>
@@ -9791,7 +10063,7 @@
               </a:defRPr>
             </a:pPr>
             <a:r>
-              <a:t>RESOURCES</a:t>
+              <a:t>HIGH / CRIT CVEs</a:t>
             </a:r>
           </a:p>
           <a:p>
@@ -9803,7 +10075,7 @@
               </a:defRPr>
             </a:pPr>
             <a:r>
-              <a:t>15 ADDED</a:t>
+              <a:t>0 BLOCKERS</a:t>
             </a:r>
           </a:p>
           <a:p>
@@ -9815,7 +10087,7 @@
               </a:defRPr>
             </a:pPr>
             <a:r>
-              <a:t>0 Changed • 0 Destroyed</a:t>
+              <a:t>Exit-Code 1 Security Policy Enforced</a:t>
             </a:r>
           </a:p>
         </p:txBody>
@@ -9870,7 +10142,7 @@
               </a:defRPr>
             </a:pPr>
             <a:r>
-              <a:t>Resilient Multi-AZ VPC</a:t>
+              <a:t>Automated Security Gate</a:t>
             </a:r>
           </a:p>
           <a:p>
@@ -9886,7 +10158,7 @@
               </a:defRPr>
             </a:pPr>
             <a:r>
-              <a:t>Custom 10.0.0.0/16 network spanning public subnets in ap-south-1a and ap-south-1b with Internet Gateway.</a:t>
+              <a:t>Aqua Security Trivy analyzes backend and frontend container filesystems directly in the CI runner.</a:t>
             </a:r>
           </a:p>
         </p:txBody>
@@ -9984,7 +10256,7 @@
               </a:defRPr>
             </a:pPr>
             <a:r>
-              <a:t>Amazon EKS 1.30 Control Plane</a:t>
+              <a:t>Debian CVE Elimination</a:t>
             </a:r>
           </a:p>
           <a:p>
@@ -10000,7 +10272,7 @@
               </a:defRPr>
             </a:pPr>
             <a:r>
-              <a:t>Managed Kubernetes control plane configured with dedicated IAM cluster roles and OIDC authentication.</a:t>
+              <a:t>Replaced Debian Slim base (48 high CVEs in util-linux/systemd) with clean, upgraded Alpine Linux.</a:t>
             </a:r>
           </a:p>
         </p:txBody>
@@ -10098,7 +10370,7 @@
               </a:defRPr>
             </a:pPr>
             <a:r>
-              <a:t>AL2023 Managed Node Group</a:t>
+              <a:t>Patched Dependencies</a:t>
             </a:r>
           </a:p>
           <a:p>
@@ -10114,7 +10386,7 @@
               </a:defRPr>
             </a:pPr>
             <a:r>
-              <a:t>Autoscaling worker nodes powered by Amazon Linux 2023 (AL2023_x86_64_STANDARD) AMI.</a:t>
+              <a:t>Updated python-multipart to &gt;=0.0.30 to remediate CVE-2026-24486, CVE-2026-42561, &amp; CVE-2026-53539.</a:t>
             </a:r>
           </a:p>
         </p:txBody>
@@ -10212,7 +10484,7 @@
               </a:defRPr>
             </a:pPr>
             <a:r>
-              <a:t>Zero Secret Exposure</a:t>
+              <a:t>FastAPI Compatibility Fix</a:t>
             </a:r>
           </a:p>
           <a:p>
@@ -10228,7 +10500,7 @@
               </a:defRPr>
             </a:pPr>
             <a:r>
-              <a:t>Modular HCL manifests with terraform.tfvars.example ensuring zero cloud credentials enter Git.</a:t>
+              <a:t>Pinned FastAPI &lt;0.137.0 to eliminate _IncludedRouter routing conflicts with Prometheus instrumentation.</a:t>
             </a:r>
           </a:p>
         </p:txBody>
@@ -10323,7 +10595,7 @@
       </p:sp>
       <p:pic>
         <p:nvPicPr>
-          <p:cNvPr id="14" name="Picture 13" descr="terraform-plan.png"/>
+          <p:cNvPr id="14" name="Picture 13" descr="github-ci-cd-pip.png"/>
           <p:cNvPicPr>
             <a:picLocks noChangeAspect="1"/>
           </p:cNvPicPr>
@@ -10337,8 +10609,8 @@
         </p:blipFill>
         <p:spPr>
           <a:xfrm>
-            <a:off x="6309360" y="2050536"/>
-            <a:ext cx="5196535" cy="3589031"/>
+            <a:off x="6309360" y="2394658"/>
+            <a:ext cx="5196535" cy="2900786"/>
           </a:xfrm>
           <a:prstGeom prst="rect">
             <a:avLst/>
@@ -10375,7 +10647,7 @@
               </a:defRPr>
             </a:pPr>
             <a:r>
-              <a:t>📷  Terraform Plan output showing successful calculation of 15 AWS infrastructure resources.</a:t>
+              <a:t>📷  Trivy Security Gate passing cleanly with zero unfixed High/Critical vulnerabilities.</a:t>
             </a:r>
           </a:p>
         </p:txBody>
@@ -10410,7 +10682,7 @@
               </a:defRPr>
             </a:pPr>
             <a:r>
-              <a:t>Autonomous Robotics Lab Operations Portal  |  Presenter: Sameer Khan  |  Slide 7 of 11</a:t>
+              <a:t>Autonomous Robotics Lab Operations Portal  |  Sameer Khan S (24BC10245)  |  Slide 7 of 12</a:t>
             </a:r>
           </a:p>
         </p:txBody>
@@ -10526,7 +10798,7 @@
               </a:defRPr>
             </a:pPr>
             <a:r>
-              <a:t>MODULE 7 — AWS MANAGEMENT CONSOLE PROOF</a:t>
+              <a:t>MODULE 7 — INFRASTRUCTURE AS CODE (TERRAFORM)</a:t>
             </a:r>
           </a:p>
           <a:p>
@@ -10539,7 +10811,7 @@
               </a:defRPr>
             </a:pPr>
             <a:r>
-              <a:t>Live Cloud Verification: Amazon EKS &amp; EC2</a:t>
+              <a:t>AWS Multi-AZ VPC &amp; EKS Cluster Provisioning</a:t>
             </a:r>
           </a:p>
           <a:p>
@@ -10552,7 +10824,7 @@
               </a:defRPr>
             </a:pPr>
             <a:r>
-              <a:t>Operational confirmation of provisioned Kubernetes cluster, worker compute, and networking</a:t>
+              <a:t>Declarative cloud infrastructure provisioning 15 AWS resources across multiple availability zones</a:t>
             </a:r>
           </a:p>
         </p:txBody>
@@ -10606,7 +10878,7 @@
               </a:defRPr>
             </a:pPr>
             <a:r>
-              <a:t>CLUSTER STATUS</a:t>
+              <a:t>RESOURCES</a:t>
             </a:r>
           </a:p>
           <a:p>
@@ -10618,7 +10890,7 @@
               </a:defRPr>
             </a:pPr>
             <a:r>
-              <a:t>ACTIVE</a:t>
+              <a:t>15 ADDED</a:t>
             </a:r>
           </a:p>
           <a:p>
@@ -10630,7 +10902,7 @@
               </a:defRPr>
             </a:pPr>
             <a:r>
-              <a:t>Kubernetes v1.30 in ap-south-1</a:t>
+              <a:t>0 Changed • 0 Destroyed</a:t>
             </a:r>
           </a:p>
         </p:txBody>
@@ -10685,7 +10957,7 @@
               </a:defRPr>
             </a:pPr>
             <a:r>
-              <a:t>EKS Control Plane Active</a:t>
+              <a:t>Resilient Multi-AZ VPC</a:t>
             </a:r>
           </a:p>
           <a:p>
@@ -10701,7 +10973,7 @@
               </a:defRPr>
             </a:pPr>
             <a:r>
-              <a:t>AWS Console confirms robotics-portal-eks operating normally with endpoint and OIDC configured.</a:t>
+              <a:t>Custom 10.0.0.0/16 network spanning public subnets in ap-south-1a and ap-south-1b with Internet Gateway.</a:t>
             </a:r>
           </a:p>
         </p:txBody>
@@ -10799,7 +11071,7 @@
               </a:defRPr>
             </a:pPr>
             <a:r>
-              <a:t>EC2 Worker Node Instances</a:t>
+              <a:t>Amazon EKS 1.30 Control Plane</a:t>
             </a:r>
           </a:p>
           <a:p>
@@ -10815,7 +11087,7 @@
               </a:defRPr>
             </a:pPr>
             <a:r>
-              <a:t>Provisioned EC2 worker nodes active, healthy, and communicating with the Kubernetes control plane.</a:t>
+              <a:t>Managed Kubernetes control plane configured with dedicated IAM cluster roles and OIDC authentication.</a:t>
             </a:r>
           </a:p>
         </p:txBody>
@@ -10913,7 +11185,7 @@
               </a:defRPr>
             </a:pPr>
             <a:r>
-              <a:t>IAM Policy Verification</a:t>
+              <a:t>AL2023 Managed Node Group</a:t>
             </a:r>
           </a:p>
           <a:p>
@@ -10929,7 +11201,7 @@
               </a:defRPr>
             </a:pPr>
             <a:r>
-              <a:t>WorkerNodePolicy, CNIPolicy, and ContainerRegistryReadOnly attached to node instance profiles.</a:t>
+              <a:t>Autoscaling worker nodes powered by Amazon Linux 2023 (AL2023_x86_64_STANDARD) AMI.</a:t>
             </a:r>
           </a:p>
         </p:txBody>
@@ -11027,7 +11299,7 @@
               </a:defRPr>
             </a:pPr>
             <a:r>
-              <a:t>Teardown Verification</a:t>
+              <a:t>Zero Secret Exposure</a:t>
             </a:r>
           </a:p>
           <a:p>
@@ -11043,7 +11315,7 @@
               </a:defRPr>
             </a:pPr>
             <a:r>
-              <a:t>Validated terraform destroy workflow guarantees zero orphaned cloud resources or runaway AWS bills.</a:t>
+              <a:t>Modular HCL manifests with terraform.tfvars.example ensuring zero cloud credentials enter Git.</a:t>
             </a:r>
           </a:p>
         </p:txBody>
@@ -11138,7 +11410,7 @@
       </p:sp>
       <p:pic>
         <p:nvPicPr>
-          <p:cNvPr id="14" name="Picture 13" descr="eks-dash.png"/>
+          <p:cNvPr id="14" name="Picture 13" descr="terraform-plan.png"/>
           <p:cNvPicPr>
             <a:picLocks noChangeAspect="1"/>
           </p:cNvPicPr>
@@ -11152,8 +11424,8 @@
         </p:blipFill>
         <p:spPr>
           <a:xfrm>
-            <a:off x="6309360" y="2387418"/>
-            <a:ext cx="5196535" cy="2915267"/>
+            <a:off x="6309360" y="2050536"/>
+            <a:ext cx="5196535" cy="3589031"/>
           </a:xfrm>
           <a:prstGeom prst="rect">
             <a:avLst/>
@@ -11190,7 +11462,7 @@
               </a:defRPr>
             </a:pPr>
             <a:r>
-              <a:t>📷  AWS Management Console showing the Amazon EKS cluster running in Active status.</a:t>
+              <a:t>📷  Terraform Plan output showing successful calculation of 15 AWS infrastructure resources.</a:t>
             </a:r>
           </a:p>
         </p:txBody>
@@ -11225,7 +11497,7 @@
               </a:defRPr>
             </a:pPr>
             <a:r>
-              <a:t>Autonomous Robotics Lab Operations Portal  |  Presenter: Sameer Khan  |  Slide 8 of 11</a:t>
+              <a:t>Autonomous Robotics Lab Operations Portal  |  Sameer Khan S (24BC10245)  |  Slide 8 of 12</a:t>
             </a:r>
           </a:p>
         </p:txBody>
@@ -11341,7 +11613,7 @@
               </a:defRPr>
             </a:pPr>
             <a:r>
-              <a:t>MODULE 8 — KUBERNETES &amp; HELM MICROSERVICES</a:t>
+              <a:t>MODULE 7 — AWS MANAGEMENT CONSOLE PROOF</a:t>
             </a:r>
           </a:p>
           <a:p>
@@ -11354,7 +11626,7 @@
               </a:defRPr>
             </a:pPr>
             <a:r>
-              <a:t>Cloud-Native Packaging &amp; Rolling Upgrades</a:t>
+              <a:t>Live Cloud Verification: Amazon EKS &amp; EC2</a:t>
             </a:r>
           </a:p>
           <a:p>
@@ -11367,7 +11639,7 @@
               </a:defRPr>
             </a:pPr>
             <a:r>
-              <a:t>Modular Helm v2 chart architecture managing multi-replica deployments and ingress routing</a:t>
+              <a:t>Operational confirmation of provisioned Kubernetes cluster, worker compute, and networking</a:t>
             </a:r>
           </a:p>
         </p:txBody>
@@ -11421,7 +11693,7 @@
               </a:defRPr>
             </a:pPr>
             <a:r>
-              <a:t>POD STATUS</a:t>
+              <a:t>CLUSTER STATUS</a:t>
             </a:r>
           </a:p>
           <a:p>
@@ -11433,7 +11705,7 @@
               </a:defRPr>
             </a:pPr>
             <a:r>
-              <a:t>100% RUNNING</a:t>
+              <a:t>ACTIVE</a:t>
             </a:r>
           </a:p>
           <a:p>
@@ -11445,7 +11717,7 @@
               </a:defRPr>
             </a:pPr>
             <a:r>
-              <a:t>Zero-Downtime Rolling Rollouts</a:t>
+              <a:t>Kubernetes v1.30 in ap-south-1</a:t>
             </a:r>
           </a:p>
         </p:txBody>
@@ -11500,7 +11772,7 @@
               </a:defRPr>
             </a:pPr>
             <a:r>
-              <a:t>Dedicated Namespace</a:t>
+              <a:t>EKS Control Plane Active</a:t>
             </a:r>
           </a:p>
           <a:p>
@@ -11516,7 +11788,7 @@
               </a:defRPr>
             </a:pPr>
             <a:r>
-              <a:t>Isolated deployment under robotics-portal namespace created via clean declarative manifest.</a:t>
+              <a:t>AWS Console confirms robotics-portal-eks operating normally with endpoint and OIDC configured.</a:t>
             </a:r>
           </a:p>
         </p:txBody>
@@ -11614,7 +11886,7 @@
               </a:defRPr>
             </a:pPr>
             <a:r>
-              <a:t>High-Availability Replicas</a:t>
+              <a:t>EC2 Worker Node Instances</a:t>
             </a:r>
           </a:p>
           <a:p>
@@ -11630,7 +11902,7 @@
               </a:defRPr>
             </a:pPr>
             <a:r>
-              <a:t>Deployments configured with 2 frontend pods, 2 backend pods, and persistent PostgreSQL.</a:t>
+              <a:t>Provisioned EC2 worker nodes active, healthy, and communicating with the Kubernetes control plane.</a:t>
             </a:r>
           </a:p>
         </p:txBody>
@@ -11728,7 +12000,7 @@
               </a:defRPr>
             </a:pPr>
             <a:r>
-              <a:t>Zero-Downtime Upgrades</a:t>
+              <a:t>IAM Policy Verification</a:t>
             </a:r>
           </a:p>
           <a:p>
@@ -11744,7 +12016,7 @@
               </a:defRPr>
             </a:pPr>
             <a:r>
-              <a:t>Automated rolling pod replacements verified via helm upgrade --install with 0 service outages.</a:t>
+              <a:t>WorkerNodePolicy, CNIPolicy, and ContainerRegistryReadOnly attached to node instance profiles.</a:t>
             </a:r>
           </a:p>
         </p:txBody>
@@ -11842,7 +12114,7 @@
               </a:defRPr>
             </a:pPr>
             <a:r>
-              <a:t>Ingress Traffic Routing</a:t>
+              <a:t>Teardown Verification</a:t>
             </a:r>
           </a:p>
           <a:p>
@@ -11858,7 +12130,7 @@
               </a:defRPr>
             </a:pPr>
             <a:r>
-              <a:t>Kubernetes Ingress routes external root traffic / to frontend and API traffic /api to backend.</a:t>
+              <a:t>Validated terraform destroy workflow guarantees zero orphaned cloud resources or runaway AWS bills.</a:t>
             </a:r>
           </a:p>
         </p:txBody>
@@ -11953,7 +12225,7 @@
       </p:sp>
       <p:pic>
         <p:nvPicPr>
-          <p:cNvPr id="14" name="Picture 13" descr="kubectl.png"/>
+          <p:cNvPr id="14" name="Picture 13" descr="eks-dash.png"/>
           <p:cNvPicPr>
             <a:picLocks noChangeAspect="1"/>
           </p:cNvPicPr>
@@ -11967,8 +12239,8 @@
         </p:blipFill>
         <p:spPr>
           <a:xfrm>
-            <a:off x="6309360" y="3007438"/>
-            <a:ext cx="5196535" cy="1675226"/>
+            <a:off x="6309360" y="2387418"/>
+            <a:ext cx="5196535" cy="2915267"/>
           </a:xfrm>
           <a:prstGeom prst="rect">
             <a:avLst/>
@@ -12005,7 +12277,7 @@
               </a:defRPr>
             </a:pPr>
             <a:r>
-              <a:t>📷  kubectl get pods verifying all frontend, backend, and database pods in Running state.</a:t>
+              <a:t>📷  AWS Management Console showing the Amazon EKS cluster running in Active status.</a:t>
             </a:r>
           </a:p>
         </p:txBody>
@@ -12040,7 +12312,7 @@
               </a:defRPr>
             </a:pPr>
             <a:r>
-              <a:t>Autonomous Robotics Lab Operations Portal  |  Presenter: Sameer Khan  |  Slide 9 of 11</a:t>
+              <a:t>Autonomous Robotics Lab Operations Portal  |  Sameer Khan S (24BC10245)  |  Slide 9 of 12</a:t>
             </a:r>
           </a:p>
         </p:txBody>

</xml_diff>